<commit_message>
Deck v5: net-new urgency, tier ladder, term flag, one-frame closer
Four approved refinements:
- The net-new-only condition is promoted from a side panel to slide 16's
  banner (every ISV Archera signs directly first is permanently off the
  rev-share) and echoed in the exec-summary kicker.
- Slide 15's Co-Seller card becomes a visual tier ladder with the sizing
  scenarios pinned to where they land (conservative in Bronze, base and
  optimistic both in Silver; Gold labelled a multi-year ambition).
- "GRI/GSP MRR" jargon replaced with "commitment MRR" (glossed once);
  slide 19 flags the agreement's 18-month auto-renewal with six months'
  notice under Delaware law.
- New slide 21 "Send this on": the whole argument in one forwardable
  frame - structure, discount ladder, the fine print, the tiers, and
  the three asks. Deck is now 21 slides.

Co-Authored-By: Claude Fable 5 <noreply@anthropic.com>
Claude-Session: https://claude.ai/code/session_012w7LGPcWj2zdqXYGvUCRmN
</commit_message>
<xml_diff>
--- a/decks/Archera-for-Automatum.pptx
+++ b/decks/Archera-for-Automatum.pptx
@@ -25,9 +25,10 @@
     <p:sldId id="273" r:id="rId19"/>
     <p:sldId id="274" r:id="rId20"/>
     <p:sldId id="275" r:id="rId21"/>
+    <p:sldId id="276" r:id="rId22"/>
   </p:sldIdLst>
   <p:notesMasterIdLst>
-    <p:notesMasterId r:id="rId22"/>
+    <p:notesMasterId r:id="rId23"/>
   </p:notesMasterIdLst>
   <p:sldSz cx="12191695" cy="6858000"/>
   <p:notesSz cx="6858000" cy="12191695"/>
@@ -1601,6 +1602,94 @@
             <a:fld id="{F7021451-1387-4CA6-816F-3879F97B5CBC}" type="slidenum">
               <a:rPr lang="en-US"/>
               <a:t>20</a:t>
+            </a:fld>
+            <a:endParaRPr lang="en-US"/>
+          </a:p>
+        </p:txBody>
+      </p:sp>
+    </p:spTree>
+    <p:extLst>
+      <p:ext uri="{BB962C8B-B14F-4D97-AF65-F5344CB8AC3E}">
+        <p14:creationId xmlns:p14="http://schemas.microsoft.com/office/powerpoint/2010/main" val="1024086991"/>
+      </p:ext>
+    </p:extLst>
+  </p:cSld>
+  <p:clrMapOvr>
+    <a:masterClrMapping/>
+  </p:clrMapOvr>
+</p:notes>
+</file>
+
+<file path=ppt/notesSlides/notesSlide21.xml><?xml version="1.0" encoding="utf-8"?>
+<p:notes xmlns:a="http://schemas.openxmlformats.org/drawingml/2006/main" xmlns:r="http://schemas.openxmlformats.org/officeDocument/2006/relationships" xmlns:p="http://schemas.openxmlformats.org/presentationml/2006/main">
+  <p:cSld>
+    <p:spTree>
+      <p:nvGrpSpPr>
+        <p:cNvPr id="1" name=""/>
+        <p:cNvGrpSpPr/>
+        <p:nvPr/>
+      </p:nvGrpSpPr>
+      <p:grpSpPr>
+        <a:xfrm>
+          <a:off x="0" y="0"/>
+          <a:ext cx="0" cy="0"/>
+          <a:chOff x="0" y="0"/>
+          <a:chExt cx="0" cy="0"/>
+        </a:xfrm>
+      </p:grpSpPr>
+      <p:sp>
+        <p:nvSpPr>
+          <p:cNvPr id="2" name="Slide Image Placeholder 1"/>
+          <p:cNvSpPr>
+            <a:spLocks noGrp="1" noRot="1" noChangeAspect="1"/>
+          </p:cNvSpPr>
+          <p:nvPr>
+            <p:ph type="sldImg"/>
+          </p:nvPr>
+        </p:nvSpPr>
+        <p:spPr/>
+      </p:sp>
+      <p:sp>
+        <p:nvSpPr>
+          <p:cNvPr id="3" name="Notes Placeholder 2"/>
+          <p:cNvSpPr>
+            <a:spLocks noGrp="1"/>
+          </p:cNvSpPr>
+          <p:nvPr>
+            <p:ph type="body" idx="1"/>
+          </p:nvPr>
+        </p:nvSpPr>
+        <p:spPr/>
+        <p:txBody>
+          <a:bodyPr/>
+          <a:lstStyle/>
+          <a:p>
+            <a:r>
+              <a:rPr lang="en-US" dirty="0"/>
+              <a:t>The forwardable slide: everything load-bearing in one frame, for the CEO to send to their team without the deck. If only one slide survives the meeting, this is the one it should be.</a:t>
+            </a:r>
+            <a:endParaRPr lang="en-US" dirty="0"/>
+          </a:p>
+        </p:txBody>
+      </p:sp>
+      <p:sp>
+        <p:nvSpPr>
+          <p:cNvPr id="4" name="Slide Number Placeholder 3"/>
+          <p:cNvSpPr>
+            <a:spLocks noGrp="1"/>
+          </p:cNvSpPr>
+          <p:nvPr>
+            <p:ph type="sldNum" sz="quarter" idx="10"/>
+          </p:nvPr>
+        </p:nvSpPr>
+        <p:spPr/>
+        <p:txBody>
+          <a:bodyPr/>
+          <a:lstStyle/>
+          <a:p>
+            <a:fld id="{F7021451-1387-4CA6-816F-3879F97B5CBC}" type="slidenum">
+              <a:rPr lang="en-US"/>
+              <a:t>21</a:t>
             </a:fld>
             <a:endParaRPr lang="en-US"/>
           </a:p>
@@ -8429,7 +8518,7 @@
         <p:spPr>
           <a:xfrm>
             <a:off x="877824" y="2395728"/>
-            <a:ext cx="4797400" cy="493776"/>
+            <a:ext cx="4797400" cy="310896"/>
           </a:xfrm>
           <a:prstGeom prst="rect">
             <a:avLst/>
@@ -8738,7 +8827,7 @@
         <p:spPr>
           <a:xfrm>
             <a:off x="6516472" y="2395728"/>
-            <a:ext cx="4797400" cy="493776"/>
+            <a:ext cx="4797400" cy="310896"/>
           </a:xfrm>
           <a:prstGeom prst="rect">
             <a:avLst/>
@@ -8779,16 +8868,137 @@
         </p:nvSpPr>
         <p:spPr>
           <a:xfrm>
-            <a:off x="6534760" y="3127248"/>
-            <a:ext cx="137160" cy="137160"/>
-          </a:xfrm>
-          <a:prstGeom prst="ellipse">
-            <a:avLst/>
+            <a:off x="6516472" y="2852928"/>
+            <a:ext cx="4797400" cy="457200"/>
+          </a:xfrm>
+          <a:prstGeom prst="roundRect">
+            <a:avLst>
+              <a:gd name="adj" fmla="val 12000"/>
+            </a:avLst>
           </a:prstGeom>
           <a:solidFill>
-            <a:srgbClr val="5566D8"/>
+            <a:srgbClr val="141A4F"/>
           </a:solidFill>
-          <a:ln w="3175">
+          <a:ln w="9525">
+            <a:solidFill>
+              <a:srgbClr val="3D4569"/>
+            </a:solidFill>
+            <a:prstDash val="solid"/>
+          </a:ln>
+        </p:spPr>
+      </p:sp>
+      <p:sp>
+        <p:nvSpPr>
+          <p:cNvPr id="18" name="Text 16"/>
+          <p:cNvSpPr txBox="1"/>
+          <p:nvPr/>
+        </p:nvSpPr>
+        <p:spPr>
+          <a:xfrm>
+            <a:off x="6681064" y="2852928"/>
+            <a:ext cx="4468216" cy="457200"/>
+          </a:xfrm>
+          <a:prstGeom prst="rect">
+            <a:avLst/>
+          </a:prstGeom>
+          <a:noFill/>
+          <a:ln/>
+        </p:spPr>
+        <p:txBody>
+          <a:bodyPr wrap="square" lIns="0" tIns="0" rIns="0" bIns="0" rtlCol="0" anchor="ctr"/>
+          <a:lstStyle/>
+          <a:p>
+            <a:pPr indent="0" marL="0">
+              <a:buNone/>
+            </a:pPr>
+            <a:r>
+              <a:rPr lang="en-US" sz="1150" b="1" dirty="0">
+                <a:solidFill>
+                  <a:srgbClr val="FFFFFF"/>
+                </a:solidFill>
+                <a:latin typeface="Calibri" pitchFamily="34" charset="0"/>
+                <a:ea typeface="Calibri" pitchFamily="34" charset="-122"/>
+                <a:cs typeface="Calibri" pitchFamily="34" charset="-120"/>
+              </a:rPr>
+              <a:t>BRONZE  20%</a:t>
+            </a:r>
+            <a:pPr indent="0" marL="0">
+              <a:buNone/>
+            </a:pPr>
+            <a:r>
+              <a:rPr lang="en-US" sz="950" dirty="0">
+                <a:solidFill>
+                  <a:srgbClr val="AAB2D0"/>
+                </a:solidFill>
+                <a:latin typeface="Calibri" pitchFamily="34" charset="0"/>
+                <a:ea typeface="Calibri" pitchFamily="34" charset="-122"/>
+                <a:cs typeface="Calibri" pitchFamily="34" charset="-120"/>
+              </a:rPr>
+              <a:t>   under $100K MRR</a:t>
+            </a:r>
+            <a:endParaRPr lang="en-US" sz="1150" dirty="0"/>
+          </a:p>
+        </p:txBody>
+      </p:sp>
+      <p:sp>
+        <p:nvSpPr>
+          <p:cNvPr id="19" name="Text 17"/>
+          <p:cNvSpPr txBox="1"/>
+          <p:nvPr/>
+        </p:nvSpPr>
+        <p:spPr>
+          <a:xfrm>
+            <a:off x="6681064" y="2852928"/>
+            <a:ext cx="4303624" cy="457200"/>
+          </a:xfrm>
+          <a:prstGeom prst="rect">
+            <a:avLst/>
+          </a:prstGeom>
+          <a:noFill/>
+          <a:ln/>
+        </p:spPr>
+        <p:txBody>
+          <a:bodyPr wrap="square" lIns="0" tIns="0" rIns="0" bIns="0" rtlCol="0" anchor="ctr"/>
+          <a:lstStyle/>
+          <a:p>
+            <a:pPr algn="r" indent="0" marL="0">
+              <a:buNone/>
+            </a:pPr>
+            <a:r>
+              <a:rPr lang="en-US" sz="850" i="1" dirty="0">
+                <a:solidFill>
+                  <a:srgbClr val="8E96C8"/>
+                </a:solidFill>
+                <a:latin typeface="Calibri" pitchFamily="34" charset="0"/>
+                <a:ea typeface="Calibri" pitchFamily="34" charset="-122"/>
+                <a:cs typeface="Calibri" pitchFamily="34" charset="-120"/>
+              </a:rPr>
+              <a:t>conservative ~$48K MRR</a:t>
+            </a:r>
+            <a:endParaRPr lang="en-US" sz="850" dirty="0"/>
+          </a:p>
+        </p:txBody>
+      </p:sp>
+      <p:sp>
+        <p:nvSpPr>
+          <p:cNvPr id="20" name="Shape 18"/>
+          <p:cNvSpPr/>
+          <p:nvPr/>
+        </p:nvSpPr>
+        <p:spPr>
+          <a:xfrm>
+            <a:off x="6516472" y="3401568"/>
+            <a:ext cx="4797400" cy="457200"/>
+          </a:xfrm>
+          <a:prstGeom prst="roundRect">
+            <a:avLst>
+              <a:gd name="adj" fmla="val 12000"/>
+            </a:avLst>
+          </a:prstGeom>
+          <a:solidFill>
+            <a:srgbClr val="3B4CC0"/>
+          </a:solidFill>
+          <a:ln w="12700">
             <a:solidFill>
               <a:srgbClr val="5566D8"/>
             </a:solidFill>
@@ -8798,41 +9008,52 @@
       </p:sp>
       <p:sp>
         <p:nvSpPr>
-          <p:cNvPr id="18" name="Text 16"/>
-          <p:cNvSpPr txBox="1"/>
-          <p:nvPr/>
-        </p:nvSpPr>
-        <p:spPr>
-          <a:xfrm>
-            <a:off x="6827368" y="2980944"/>
-            <a:ext cx="4486504" cy="512064"/>
-          </a:xfrm>
-          <a:prstGeom prst="rect">
-            <a:avLst/>
-          </a:prstGeom>
-          <a:noFill/>
-          <a:ln/>
-        </p:spPr>
-        <p:txBody>
-          <a:bodyPr wrap="square" lIns="0" tIns="0" rIns="0" bIns="0" rtlCol="0" anchor="ctr"/>
-          <a:lstStyle/>
-          <a:p>
-            <a:pPr indent="0" marL="0">
-              <a:lnSpc>
-                <a:spcPts val="1550"/>
-              </a:lnSpc>
-              <a:buNone/>
-            </a:pPr>
-            <a:r>
-              <a:rPr lang="en-US" sz="1150" dirty="0">
-                <a:solidFill>
-                  <a:srgbClr val="B7C0E0"/>
-                </a:solidFill>
-                <a:latin typeface="Calibri" pitchFamily="34" charset="0"/>
-                <a:ea typeface="Calibri" pitchFamily="34" charset="-122"/>
-                <a:cs typeface="Calibri" pitchFamily="34" charset="-120"/>
-              </a:rPr>
-              <a:t>Bronze 20% under $100K GRI/GSP MRR, Silver 25% under $500K, Gold 30% at $1M+.</a:t>
+          <p:cNvPr id="21" name="Text 19"/>
+          <p:cNvSpPr txBox="1"/>
+          <p:nvPr/>
+        </p:nvSpPr>
+        <p:spPr>
+          <a:xfrm>
+            <a:off x="6681064" y="3401568"/>
+            <a:ext cx="4468216" cy="457200"/>
+          </a:xfrm>
+          <a:prstGeom prst="rect">
+            <a:avLst/>
+          </a:prstGeom>
+          <a:noFill/>
+          <a:ln/>
+        </p:spPr>
+        <p:txBody>
+          <a:bodyPr wrap="square" lIns="0" tIns="0" rIns="0" bIns="0" rtlCol="0" anchor="ctr"/>
+          <a:lstStyle/>
+          <a:p>
+            <a:pPr indent="0" marL="0">
+              <a:buNone/>
+            </a:pPr>
+            <a:r>
+              <a:rPr lang="en-US" sz="1150" b="1" dirty="0">
+                <a:solidFill>
+                  <a:srgbClr val="FFFFFF"/>
+                </a:solidFill>
+                <a:latin typeface="Calibri" pitchFamily="34" charset="0"/>
+                <a:ea typeface="Calibri" pitchFamily="34" charset="-122"/>
+                <a:cs typeface="Calibri" pitchFamily="34" charset="-120"/>
+              </a:rPr>
+              <a:t>SILVER  25%</a:t>
+            </a:r>
+            <a:pPr indent="0" marL="0">
+              <a:buNone/>
+            </a:pPr>
+            <a:r>
+              <a:rPr lang="en-US" sz="950" dirty="0">
+                <a:solidFill>
+                  <a:srgbClr val="C4CBEC"/>
+                </a:solidFill>
+                <a:latin typeface="Calibri" pitchFamily="34" charset="0"/>
+                <a:ea typeface="Calibri" pitchFamily="34" charset="-122"/>
+                <a:cs typeface="Calibri" pitchFamily="34" charset="-120"/>
+              </a:rPr>
+              <a:t>   under $500K</a:t>
             </a:r>
             <a:endParaRPr lang="en-US" sz="1150" dirty="0"/>
           </a:p>
@@ -8840,24 +9061,65 @@
       </p:sp>
       <p:sp>
         <p:nvSpPr>
-          <p:cNvPr id="19" name="Shape 17"/>
+          <p:cNvPr id="22" name="Text 20"/>
+          <p:cNvSpPr txBox="1"/>
+          <p:nvPr/>
+        </p:nvSpPr>
+        <p:spPr>
+          <a:xfrm>
+            <a:off x="6681064" y="3401568"/>
+            <a:ext cx="4303624" cy="457200"/>
+          </a:xfrm>
+          <a:prstGeom prst="rect">
+            <a:avLst/>
+          </a:prstGeom>
+          <a:noFill/>
+          <a:ln/>
+        </p:spPr>
+        <p:txBody>
+          <a:bodyPr wrap="square" lIns="0" tIns="0" rIns="0" bIns="0" rtlCol="0" anchor="ctr"/>
+          <a:lstStyle/>
+          <a:p>
+            <a:pPr algn="r" indent="0" marL="0">
+              <a:buNone/>
+            </a:pPr>
+            <a:r>
+              <a:rPr lang="en-US" sz="850" i="1" dirty="0">
+                <a:solidFill>
+                  <a:srgbClr val="C4CBEC"/>
+                </a:solidFill>
+                <a:latin typeface="Calibri" pitchFamily="34" charset="0"/>
+                <a:ea typeface="Calibri" pitchFamily="34" charset="-122"/>
+                <a:cs typeface="Calibri" pitchFamily="34" charset="-120"/>
+              </a:rPr>
+              <a:t>base ~$119K · optimistic ~$238K</a:t>
+            </a:r>
+            <a:endParaRPr lang="en-US" sz="850" dirty="0"/>
+          </a:p>
+        </p:txBody>
+      </p:sp>
+      <p:sp>
+        <p:nvSpPr>
+          <p:cNvPr id="23" name="Shape 21"/>
           <p:cNvSpPr/>
           <p:nvPr/>
         </p:nvSpPr>
         <p:spPr>
           <a:xfrm>
-            <a:off x="6534760" y="3730752"/>
-            <a:ext cx="137160" cy="137160"/>
-          </a:xfrm>
-          <a:prstGeom prst="ellipse">
-            <a:avLst/>
+            <a:off x="6516472" y="3950208"/>
+            <a:ext cx="4797400" cy="457200"/>
+          </a:xfrm>
+          <a:prstGeom prst="roundRect">
+            <a:avLst>
+              <a:gd name="adj" fmla="val 12000"/>
+            </a:avLst>
           </a:prstGeom>
           <a:solidFill>
-            <a:srgbClr val="5566D8"/>
+            <a:srgbClr val="141A4F"/>
           </a:solidFill>
-          <a:ln w="3175">
+          <a:ln w="9525">
             <a:solidFill>
-              <a:srgbClr val="5566D8"/>
+              <a:srgbClr val="3D4569"/>
             </a:solidFill>
             <a:prstDash val="solid"/>
           </a:ln>
@@ -8865,116 +9127,180 @@
       </p:sp>
       <p:sp>
         <p:nvSpPr>
-          <p:cNvPr id="20" name="Text 18"/>
-          <p:cNvSpPr txBox="1"/>
-          <p:nvPr/>
-        </p:nvSpPr>
-        <p:spPr>
-          <a:xfrm>
-            <a:off x="6827368" y="3584448"/>
-            <a:ext cx="4486504" cy="512064"/>
-          </a:xfrm>
-          <a:prstGeom prst="rect">
-            <a:avLst/>
-          </a:prstGeom>
-          <a:noFill/>
-          <a:ln/>
-        </p:spPr>
-        <p:txBody>
-          <a:bodyPr wrap="square" lIns="0" tIns="0" rIns="0" bIns="0" rtlCol="0" anchor="ctr"/>
+          <p:cNvPr id="24" name="Text 22"/>
+          <p:cNvSpPr txBox="1"/>
+          <p:nvPr/>
+        </p:nvSpPr>
+        <p:spPr>
+          <a:xfrm>
+            <a:off x="6681064" y="3950208"/>
+            <a:ext cx="4468216" cy="457200"/>
+          </a:xfrm>
+          <a:prstGeom prst="rect">
+            <a:avLst/>
+          </a:prstGeom>
+          <a:noFill/>
+          <a:ln/>
+        </p:spPr>
+        <p:txBody>
+          <a:bodyPr wrap="square" lIns="0" tIns="0" rIns="0" bIns="0" rtlCol="0" anchor="ctr"/>
+          <a:lstStyle/>
+          <a:p>
+            <a:pPr indent="0" marL="0">
+              <a:buNone/>
+            </a:pPr>
+            <a:r>
+              <a:rPr lang="en-US" sz="1150" b="1" dirty="0">
+                <a:solidFill>
+                  <a:srgbClr val="FFFFFF"/>
+                </a:solidFill>
+                <a:latin typeface="Calibri" pitchFamily="34" charset="0"/>
+                <a:ea typeface="Calibri" pitchFamily="34" charset="-122"/>
+                <a:cs typeface="Calibri" pitchFamily="34" charset="-120"/>
+              </a:rPr>
+              <a:t>GOLD  30%</a:t>
+            </a:r>
+            <a:pPr indent="0" marL="0">
+              <a:buNone/>
+            </a:pPr>
+            <a:r>
+              <a:rPr lang="en-US" sz="950" dirty="0">
+                <a:solidFill>
+                  <a:srgbClr val="AAB2D0"/>
+                </a:solidFill>
+                <a:latin typeface="Calibri" pitchFamily="34" charset="0"/>
+                <a:ea typeface="Calibri" pitchFamily="34" charset="-122"/>
+                <a:cs typeface="Calibri" pitchFamily="34" charset="-120"/>
+              </a:rPr>
+              <a:t>   $1M+ MRR</a:t>
+            </a:r>
+            <a:endParaRPr lang="en-US" sz="1150" dirty="0"/>
+          </a:p>
+        </p:txBody>
+      </p:sp>
+      <p:sp>
+        <p:nvSpPr>
+          <p:cNvPr id="25" name="Text 23"/>
+          <p:cNvSpPr txBox="1"/>
+          <p:nvPr/>
+        </p:nvSpPr>
+        <p:spPr>
+          <a:xfrm>
+            <a:off x="6681064" y="3950208"/>
+            <a:ext cx="4303624" cy="457200"/>
+          </a:xfrm>
+          <a:prstGeom prst="rect">
+            <a:avLst/>
+          </a:prstGeom>
+          <a:noFill/>
+          <a:ln/>
+        </p:spPr>
+        <p:txBody>
+          <a:bodyPr wrap="square" lIns="0" tIns="0" rIns="0" bIns="0" rtlCol="0" anchor="ctr"/>
+          <a:lstStyle/>
+          <a:p>
+            <a:pPr algn="r" indent="0" marL="0">
+              <a:buNone/>
+            </a:pPr>
+            <a:r>
+              <a:rPr lang="en-US" sz="850" i="1" dirty="0">
+                <a:solidFill>
+                  <a:srgbClr val="8E96C8"/>
+                </a:solidFill>
+                <a:latin typeface="Calibri" pitchFamily="34" charset="0"/>
+                <a:ea typeface="Calibri" pitchFamily="34" charset="-122"/>
+                <a:cs typeface="Calibri" pitchFamily="34" charset="-120"/>
+              </a:rPr>
+              <a:t>a multi-year ambition</a:t>
+            </a:r>
+            <a:endParaRPr lang="en-US" sz="850" dirty="0"/>
+          </a:p>
+        </p:txBody>
+      </p:sp>
+      <p:sp>
+        <p:nvSpPr>
+          <p:cNvPr id="26" name="Text 24"/>
+          <p:cNvSpPr txBox="1"/>
+          <p:nvPr/>
+        </p:nvSpPr>
+        <p:spPr>
+          <a:xfrm>
+            <a:off x="6516472" y="4535424"/>
+            <a:ext cx="4797400" cy="256032"/>
+          </a:xfrm>
+          <a:prstGeom prst="rect">
+            <a:avLst/>
+          </a:prstGeom>
+          <a:noFill/>
+          <a:ln/>
+        </p:spPr>
+        <p:txBody>
+          <a:bodyPr wrap="square" lIns="0" tIns="0" rIns="0" bIns="0" rtlCol="0" anchor="ctr"/>
+          <a:lstStyle/>
+          <a:p>
+            <a:pPr indent="0" marL="0">
+              <a:buNone/>
+            </a:pPr>
+            <a:r>
+              <a:rPr lang="en-US" sz="1000" dirty="0">
+                <a:solidFill>
+                  <a:srgbClr val="B7C0E0"/>
+                </a:solidFill>
+                <a:latin typeface="Calibri" pitchFamily="34" charset="0"/>
+                <a:ea typeface="Calibri" pitchFamily="34" charset="-122"/>
+                <a:cs typeface="Calibri" pitchFamily="34" charset="-120"/>
+              </a:rPr>
+              <a:t>Automatum runs the motion with joint GTM support; Archera provides Tier-2 support.</a:t>
+            </a:r>
+            <a:endParaRPr lang="en-US" sz="1000" dirty="0"/>
+          </a:p>
+        </p:txBody>
+      </p:sp>
+      <p:sp>
+        <p:nvSpPr>
+          <p:cNvPr id="27" name="Text 25"/>
+          <p:cNvSpPr txBox="1"/>
+          <p:nvPr/>
+        </p:nvSpPr>
+        <p:spPr>
+          <a:xfrm>
+            <a:off x="566928" y="6089904"/>
+            <a:ext cx="11057839" cy="274320"/>
+          </a:xfrm>
+          <a:prstGeom prst="rect">
+            <a:avLst/>
+          </a:prstGeom>
+          <a:noFill/>
+          <a:ln/>
+        </p:spPr>
+        <p:txBody>
+          <a:bodyPr wrap="square" lIns="0" tIns="0" rIns="0" bIns="0" rtlCol="0" anchor="t"/>
           <a:lstStyle/>
           <a:p>
             <a:pPr indent="0" marL="0">
               <a:lnSpc>
-                <a:spcPts val="1550"/>
+                <a:spcPts val="1100"/>
               </a:lnSpc>
               <a:buNone/>
             </a:pPr>
             <a:r>
-              <a:rPr lang="en-US" sz="1150" dirty="0">
-                <a:solidFill>
-                  <a:srgbClr val="B7C0E0"/>
-                </a:solidFill>
-                <a:latin typeface="Calibri" pitchFamily="34" charset="0"/>
-                <a:ea typeface="Calibri" pitchFamily="34" charset="-122"/>
-                <a:cs typeface="Calibri" pitchFamily="34" charset="-120"/>
-              </a:rPr>
-              <a:t>Automatum runs the motion with joint GTM support; Archera provides Tier-2 support.</a:t>
-            </a:r>
-            <a:endParaRPr lang="en-US" sz="1150" dirty="0"/>
-          </a:p>
-        </p:txBody>
-      </p:sp>
-      <p:sp>
-        <p:nvSpPr>
-          <p:cNvPr id="21" name="Shape 19"/>
-          <p:cNvSpPr/>
-          <p:nvPr/>
-        </p:nvSpPr>
-        <p:spPr>
-          <a:xfrm>
-            <a:off x="6534760" y="4334256"/>
-            <a:ext cx="137160" cy="137160"/>
-          </a:xfrm>
-          <a:prstGeom prst="ellipse">
-            <a:avLst/>
-          </a:prstGeom>
-          <a:solidFill>
-            <a:srgbClr val="5566D8"/>
-          </a:solidFill>
-          <a:ln w="3175">
-            <a:solidFill>
-              <a:srgbClr val="5566D8"/>
-            </a:solidFill>
-            <a:prstDash val="solid"/>
-          </a:ln>
-        </p:spPr>
-      </p:sp>
-      <p:sp>
-        <p:nvSpPr>
-          <p:cNvPr id="22" name="Text 20"/>
-          <p:cNvSpPr txBox="1"/>
-          <p:nvPr/>
-        </p:nvSpPr>
-        <p:spPr>
-          <a:xfrm>
-            <a:off x="6827368" y="4187952"/>
-            <a:ext cx="4486504" cy="512064"/>
-          </a:xfrm>
-          <a:prstGeom prst="rect">
-            <a:avLst/>
-          </a:prstGeom>
-          <a:noFill/>
-          <a:ln/>
-        </p:spPr>
-        <p:txBody>
-          <a:bodyPr wrap="square" lIns="0" tIns="0" rIns="0" bIns="0" rtlCol="0" anchor="ctr"/>
-          <a:lstStyle/>
-          <a:p>
-            <a:pPr indent="0" marL="0">
-              <a:lnSpc>
-                <a:spcPts val="1550"/>
-              </a:lnSpc>
-              <a:buNone/>
-            </a:pPr>
-            <a:r>
-              <a:rPr lang="en-US" sz="1150" dirty="0">
-                <a:solidFill>
-                  <a:srgbClr val="B7C0E0"/>
-                </a:solidFill>
-                <a:latin typeface="Calibri" pitchFamily="34" charset="0"/>
-                <a:ea typeface="Calibri" pitchFamily="34" charset="-122"/>
-                <a:cs typeface="Calibri" pitchFamily="34" charset="-120"/>
-              </a:rPr>
-              <a:t>The rails — CPPO, metering, the Partner Portal — are on the next slide.</a:t>
-            </a:r>
-            <a:endParaRPr lang="en-US" sz="1150" dirty="0"/>
-          </a:p>
-        </p:txBody>
-      </p:sp>
-      <p:sp>
-        <p:nvSpPr>
-          <p:cNvPr id="23" name="Shape 21"/>
+              <a:rPr lang="en-US" sz="850" i="1" dirty="0">
+                <a:solidFill>
+                  <a:srgbClr val="5B6486"/>
+                </a:solidFill>
+                <a:latin typeface="Calibri" pitchFamily="34" charset="0"/>
+                <a:ea typeface="Calibri" pitchFamily="34" charset="-122"/>
+                <a:cs typeface="Calibri" pitchFamily="34" charset="-120"/>
+              </a:rPr>
+              <a:t>Tier bands measured on commitment MRR — Archera's GRI/GSP (Guaranteed RI and Savings Plan) revenue across the partner's book. Scenario placements per the slide 6 model (premium pool ÷ 12).</a:t>
+            </a:r>
+            <a:endParaRPr lang="en-US" sz="850" dirty="0"/>
+          </a:p>
+        </p:txBody>
+      </p:sp>
+      <p:sp>
+        <p:nvSpPr>
+          <p:cNvPr id="28" name="Shape 26"/>
           <p:cNvSpPr/>
           <p:nvPr/>
         </p:nvSpPr>
@@ -9001,7 +9327,7 @@
       </p:sp>
       <p:sp>
         <p:nvSpPr>
-          <p:cNvPr id="24" name="Text 22"/>
+          <p:cNvPr id="29" name="Text 27"/>
           <p:cNvSpPr txBox="1"/>
           <p:nvPr/>
         </p:nvSpPr>
@@ -9060,7 +9386,7 @@
       </p:sp>
       <p:sp>
         <p:nvSpPr>
-          <p:cNvPr id="25" name="Text 23"/>
+          <p:cNvPr id="30" name="Text 28"/>
           <p:cNvSpPr txBox="1"/>
           <p:nvPr/>
         </p:nvSpPr>
@@ -9099,7 +9425,7 @@
       </p:sp>
       <p:sp>
         <p:nvSpPr>
-          <p:cNvPr id="26" name="Text 24"/>
+          <p:cNvPr id="31" name="Text 29"/>
           <p:cNvSpPr txBox="1"/>
           <p:nvPr/>
         </p:nvSpPr>
@@ -10401,9 +10727,9 @@
           <a:solidFill>
             <a:srgbClr val="141A4F"/>
           </a:solidFill>
-          <a:ln w="9525">
+          <a:ln w="12700">
             <a:solidFill>
-              <a:srgbClr val="3D4569"/>
+              <a:srgbClr val="F5A623"/>
             </a:solidFill>
             <a:prstDash val="solid"/>
           </a:ln>
@@ -10431,20 +10757,26 @@
           <a:lstStyle/>
           <a:p>
             <a:pPr indent="0" marL="0">
+              <a:lnSpc>
+                <a:spcPts val="1700"/>
+              </a:lnSpc>
               <a:buNone/>
             </a:pPr>
             <a:r>
               <a:rPr lang="en-US" sz="1200" b="1" dirty="0">
                 <a:solidFill>
-                  <a:srgbClr val="FFFFFF"/>
-                </a:solidFill>
-                <a:latin typeface="Calibri" pitchFamily="34" charset="0"/>
-                <a:ea typeface="Calibri" pitchFamily="34" charset="-122"/>
-                <a:cs typeface="Calibri" pitchFamily="34" charset="-120"/>
-              </a:rPr>
-              <a:t>For the ISV, the charge is marketplace spend. </a:t>
-            </a:r>
-            <a:pPr indent="0" marL="0">
+                  <a:srgbClr val="F5A623"/>
+                </a:solidFill>
+                <a:latin typeface="Calibri" pitchFamily="34" charset="0"/>
+                <a:ea typeface="Calibri" pitchFamily="34" charset="-122"/>
+                <a:cs typeface="Calibri" pitchFamily="34" charset="-120"/>
+              </a:rPr>
+              <a:t>Rev-share counts net-new Archera customers only. </a:t>
+            </a:r>
+            <a:pPr indent="0" marL="0">
+              <a:lnSpc>
+                <a:spcPts val="1700"/>
+              </a:lnSpc>
               <a:buNone/>
             </a:pPr>
             <a:r>
@@ -10456,7 +10788,7 @@
                 <a:ea typeface="Calibri" pitchFamily="34" charset="-122"/>
                 <a:cs typeface="Calibri" pitchFamily="34" charset="-120"/>
               </a:rPr>
-              <a:t>It consolidates onto the AWS invoice and draws down committed spend they were going to burn anyway.</a:t>
+              <a:t>Every ISV Archera signs directly first is permanently off Automatum's rev-share — the strongest argument for moving first. For the ISV, the charge is simply marketplace spend on the AWS invoice.</a:t>
             </a:r>
             <a:endParaRPr lang="en-US" sz="1200" dirty="0"/>
           </a:p>
@@ -14801,6 +15133,48 @@
         </p:nvSpPr>
         <p:spPr>
           <a:xfrm>
+            <a:off x="566928" y="6181344"/>
+            <a:ext cx="11057839" cy="274320"/>
+          </a:xfrm>
+          <a:prstGeom prst="rect">
+            <a:avLst/>
+          </a:prstGeom>
+          <a:noFill/>
+          <a:ln/>
+        </p:spPr>
+        <p:txBody>
+          <a:bodyPr wrap="square" lIns="0" tIns="0" rIns="0" bIns="0" rtlCol="0" anchor="t"/>
+          <a:lstStyle/>
+          <a:p>
+            <a:pPr indent="0" marL="0">
+              <a:lnSpc>
+                <a:spcPts val="1100"/>
+              </a:lnSpc>
+              <a:buNone/>
+            </a:pPr>
+            <a:r>
+              <a:rPr lang="en-US" sz="850" i="1" dirty="0">
+                <a:solidFill>
+                  <a:srgbClr val="5B6486"/>
+                </a:solidFill>
+                <a:latin typeface="Calibri" pitchFamily="34" charset="0"/>
+                <a:ea typeface="Calibri" pitchFamily="34" charset="-122"/>
+                <a:cs typeface="Calibri" pitchFamily="34" charset="-120"/>
+              </a:rPr>
+              <a:t>Also review the agreement's term before signing: it auto-renews in 18-month cycles unless terminated with at least six months' written notice, under Delaware law.</a:t>
+            </a:r>
+            <a:endParaRPr lang="en-US" sz="850" dirty="0"/>
+          </a:p>
+        </p:txBody>
+      </p:sp>
+      <p:sp>
+        <p:nvSpPr>
+          <p:cNvPr id="21" name="Text 19"/>
+          <p:cNvSpPr txBox="1"/>
+          <p:nvPr/>
+        </p:nvSpPr>
+        <p:spPr>
+          <a:xfrm>
             <a:off x="566928" y="6345936"/>
             <a:ext cx="4572000" cy="256032"/>
           </a:xfrm>
@@ -14834,7 +15208,7 @@
       </p:sp>
       <p:sp>
         <p:nvSpPr>
-          <p:cNvPr id="21" name="Text 19"/>
+          <p:cNvPr id="22" name="Text 20"/>
           <p:cNvSpPr txBox="1"/>
           <p:nvPr/>
         </p:nvSpPr>
@@ -17763,6 +18137,1976 @@
 </p:sld>
 </file>
 
+<file path=ppt/slides/slide21.xml><?xml version="1.0" encoding="utf-8"?>
+<p:sld xmlns:a="http://schemas.openxmlformats.org/drawingml/2006/main" xmlns:r="http://schemas.openxmlformats.org/officeDocument/2006/relationships" xmlns:p="http://schemas.openxmlformats.org/presentationml/2006/main">
+  <p:cSld name="Slide 21">
+    <p:bg>
+      <p:bgPr>
+        <a:solidFill>
+          <a:srgbClr val="05060F"/>
+        </a:solidFill>
+      </p:bgPr>
+    </p:bg>
+    <p:spTree>
+      <p:nvGrpSpPr>
+        <p:cNvPr id="1" name=""/>
+        <p:cNvGrpSpPr/>
+        <p:nvPr/>
+      </p:nvGrpSpPr>
+      <p:grpSpPr>
+        <a:xfrm>
+          <a:off x="0" y="0"/>
+          <a:ext cx="0" cy="0"/>
+          <a:chOff x="0" y="0"/>
+          <a:chExt cx="0" cy="0"/>
+        </a:xfrm>
+      </p:grpSpPr>
+      <p:sp>
+        <p:nvSpPr>
+          <p:cNvPr id="2" name="Text 0"/>
+          <p:cNvSpPr txBox="1"/>
+          <p:nvPr/>
+        </p:nvSpPr>
+        <p:spPr>
+          <a:xfrm>
+            <a:off x="566928" y="365760"/>
+            <a:ext cx="11057839" cy="237744"/>
+          </a:xfrm>
+          <a:prstGeom prst="rect">
+            <a:avLst/>
+          </a:prstGeom>
+          <a:noFill/>
+          <a:ln/>
+        </p:spPr>
+        <p:txBody>
+          <a:bodyPr wrap="square" lIns="0" tIns="0" rIns="0" bIns="0" rtlCol="0" anchor="ctr"/>
+          <a:lstStyle/>
+          <a:p>
+            <a:pPr indent="0" marL="0">
+              <a:buNone/>
+            </a:pPr>
+            <a:r>
+              <a:rPr lang="en-US" sz="1000" b="1" spc="260" kern="0" dirty="0">
+                <a:solidFill>
+                  <a:srgbClr val="19C6E6"/>
+                </a:solidFill>
+                <a:latin typeface="Calibri" pitchFamily="34" charset="0"/>
+                <a:ea typeface="Calibri" pitchFamily="34" charset="-122"/>
+                <a:cs typeface="Calibri" pitchFamily="34" charset="-120"/>
+              </a:rPr>
+              <a:t>SEND THIS ON</a:t>
+            </a:r>
+            <a:endParaRPr lang="en-US" sz="1000" dirty="0"/>
+          </a:p>
+        </p:txBody>
+      </p:sp>
+      <p:sp>
+        <p:nvSpPr>
+          <p:cNvPr id="3" name="Text 1"/>
+          <p:cNvSpPr txBox="1"/>
+          <p:nvPr/>
+        </p:nvSpPr>
+        <p:spPr>
+          <a:xfrm>
+            <a:off x="566928" y="658368"/>
+            <a:ext cx="11057839" cy="457200"/>
+          </a:xfrm>
+          <a:prstGeom prst="rect">
+            <a:avLst/>
+          </a:prstGeom>
+          <a:noFill/>
+          <a:ln/>
+        </p:spPr>
+        <p:txBody>
+          <a:bodyPr wrap="square" lIns="0" tIns="0" rIns="0" bIns="0" rtlCol="0" anchor="t"/>
+          <a:lstStyle/>
+          <a:p>
+            <a:pPr indent="0" marL="0">
+              <a:lnSpc>
+                <a:spcPts val="3400"/>
+              </a:lnSpc>
+              <a:buNone/>
+            </a:pPr>
+            <a:r>
+              <a:rPr lang="en-US" sz="2600" b="1" dirty="0">
+                <a:solidFill>
+                  <a:srgbClr val="FFFFFF"/>
+                </a:solidFill>
+                <a:latin typeface="Calibri" pitchFamily="34" charset="0"/>
+                <a:ea typeface="Calibri" pitchFamily="34" charset="-122"/>
+                <a:cs typeface="Calibri" pitchFamily="34" charset="-120"/>
+              </a:rPr>
+              <a:t>Archera × Automatum, in one frame.</a:t>
+            </a:r>
+            <a:endParaRPr lang="en-US" sz="2600" dirty="0"/>
+          </a:p>
+        </p:txBody>
+      </p:sp>
+      <p:sp>
+        <p:nvSpPr>
+          <p:cNvPr id="4" name="Text 2"/>
+          <p:cNvSpPr txBox="1"/>
+          <p:nvPr/>
+        </p:nvSpPr>
+        <p:spPr>
+          <a:xfrm>
+            <a:off x="566928" y="1133856"/>
+            <a:ext cx="7315200" cy="548640"/>
+          </a:xfrm>
+          <a:prstGeom prst="rect">
+            <a:avLst/>
+          </a:prstGeom>
+          <a:noFill/>
+          <a:ln/>
+        </p:spPr>
+        <p:txBody>
+          <a:bodyPr wrap="square" lIns="0" tIns="0" rIns="0" bIns="0" rtlCol="0" anchor="t"/>
+          <a:lstStyle/>
+          <a:p>
+            <a:pPr indent="0" marL="0">
+              <a:lnSpc>
+                <a:spcPts val="1900"/>
+              </a:lnSpc>
+              <a:buNone/>
+            </a:pPr>
+            <a:r>
+              <a:rPr lang="en-US" sz="1200" dirty="0">
+                <a:solidFill>
+                  <a:srgbClr val="B7C0E0"/>
+                </a:solidFill>
+                <a:latin typeface="Calibri" pitchFamily="34" charset="0"/>
+                <a:ea typeface="Calibri" pitchFamily="34" charset="-122"/>
+                <a:cs typeface="Calibri" pitchFamily="34" charset="-120"/>
+              </a:rPr>
+              <a:t>The whole argument, for whoever was not in the room.</a:t>
+            </a:r>
+            <a:endParaRPr lang="en-US" sz="1200" dirty="0"/>
+          </a:p>
+        </p:txBody>
+      </p:sp>
+      <p:sp>
+        <p:nvSpPr>
+          <p:cNvPr id="5" name="Shape 3"/>
+          <p:cNvSpPr/>
+          <p:nvPr/>
+        </p:nvSpPr>
+        <p:spPr>
+          <a:xfrm>
+            <a:off x="566928" y="1627632"/>
+            <a:ext cx="3551834" cy="4169664"/>
+          </a:xfrm>
+          <a:prstGeom prst="roundRect">
+            <a:avLst>
+              <a:gd name="adj" fmla="val 1802"/>
+            </a:avLst>
+          </a:prstGeom>
+          <a:solidFill>
+            <a:srgbClr val="141A4F"/>
+          </a:solidFill>
+          <a:ln w="9525">
+            <a:solidFill>
+              <a:srgbClr val="3D4569"/>
+            </a:solidFill>
+            <a:prstDash val="solid"/>
+          </a:ln>
+        </p:spPr>
+      </p:sp>
+      <p:sp>
+        <p:nvSpPr>
+          <p:cNvPr id="6" name="Text 4"/>
+          <p:cNvSpPr txBox="1"/>
+          <p:nvPr/>
+        </p:nvSpPr>
+        <p:spPr>
+          <a:xfrm>
+            <a:off x="822960" y="1810512"/>
+            <a:ext cx="3039770" cy="201168"/>
+          </a:xfrm>
+          <a:prstGeom prst="rect">
+            <a:avLst/>
+          </a:prstGeom>
+          <a:noFill/>
+          <a:ln/>
+        </p:spPr>
+        <p:txBody>
+          <a:bodyPr wrap="square" lIns="0" tIns="0" rIns="0" bIns="0" rtlCol="0" anchor="ctr"/>
+          <a:lstStyle/>
+          <a:p>
+            <a:pPr indent="0" marL="0">
+              <a:buNone/>
+            </a:pPr>
+            <a:r>
+              <a:rPr lang="en-US" sz="900" b="1" spc="200" kern="0" dirty="0">
+                <a:solidFill>
+                  <a:srgbClr val="5566D8"/>
+                </a:solidFill>
+                <a:latin typeface="Calibri" pitchFamily="34" charset="0"/>
+                <a:ea typeface="Calibri" pitchFamily="34" charset="-122"/>
+                <a:cs typeface="Calibri" pitchFamily="34" charset="-120"/>
+              </a:rPr>
+              <a:t>THE STRUCTURE</a:t>
+            </a:r>
+            <a:endParaRPr lang="en-US" sz="900" dirty="0"/>
+          </a:p>
+        </p:txBody>
+      </p:sp>
+      <p:sp>
+        <p:nvSpPr>
+          <p:cNvPr id="7" name="Text 5"/>
+          <p:cNvSpPr txBox="1"/>
+          <p:nvPr/>
+        </p:nvSpPr>
+        <p:spPr>
+          <a:xfrm>
+            <a:off x="822960" y="2084832"/>
+            <a:ext cx="3039770" cy="566928"/>
+          </a:xfrm>
+          <a:prstGeom prst="rect">
+            <a:avLst/>
+          </a:prstGeom>
+          <a:noFill/>
+          <a:ln/>
+        </p:spPr>
+        <p:txBody>
+          <a:bodyPr wrap="square" lIns="0" tIns="0" rIns="0" bIns="0" rtlCol="0" anchor="t"/>
+          <a:lstStyle/>
+          <a:p>
+            <a:pPr indent="0" marL="0">
+              <a:lnSpc>
+                <a:spcPts val="1350"/>
+              </a:lnSpc>
+              <a:buNone/>
+            </a:pPr>
+            <a:r>
+              <a:rPr lang="en-US" sz="1000" dirty="0">
+                <a:solidFill>
+                  <a:srgbClr val="B7C0E0"/>
+                </a:solidFill>
+                <a:latin typeface="Calibri" pitchFamily="34" charset="0"/>
+                <a:ea typeface="Calibri" pitchFamily="34" charset="-122"/>
+                <a:cs typeface="Calibri" pitchFamily="34" charset="-120"/>
+              </a:rPr>
+              <a:t>A native 3-year RI or Savings Plan, bought into the customer's own payer account.</a:t>
+            </a:r>
+            <a:endParaRPr lang="en-US" sz="1000" dirty="0"/>
+          </a:p>
+        </p:txBody>
+      </p:sp>
+      <p:sp>
+        <p:nvSpPr>
+          <p:cNvPr id="8" name="Text 6"/>
+          <p:cNvSpPr txBox="1"/>
+          <p:nvPr/>
+        </p:nvSpPr>
+        <p:spPr>
+          <a:xfrm>
+            <a:off x="822960" y="2688336"/>
+            <a:ext cx="3039770" cy="566928"/>
+          </a:xfrm>
+          <a:prstGeom prst="rect">
+            <a:avLst/>
+          </a:prstGeom>
+          <a:noFill/>
+          <a:ln/>
+        </p:spPr>
+        <p:txBody>
+          <a:bodyPr wrap="square" lIns="0" tIns="0" rIns="0" bIns="0" rtlCol="0" anchor="t"/>
+          <a:lstStyle/>
+          <a:p>
+            <a:pPr indent="0" marL="0">
+              <a:lnSpc>
+                <a:spcPts val="1350"/>
+              </a:lnSpc>
+              <a:buNone/>
+            </a:pPr>
+            <a:r>
+              <a:rPr lang="en-US" sz="1000" dirty="0">
+                <a:solidFill>
+                  <a:srgbClr val="B7C0E0"/>
+                </a:solidFill>
+                <a:latin typeface="Calibri" pitchFamily="34" charset="0"/>
+                <a:ea typeface="Calibri" pitchFamily="34" charset="-122"/>
+                <a:cs typeface="Calibri" pitchFamily="34" charset="-120"/>
+              </a:rPr>
+              <a:t>Their obligation: 30 days or 12 months. Archera carries the balance; AWS bills them directly.</a:t>
+            </a:r>
+            <a:endParaRPr lang="en-US" sz="1000" dirty="0"/>
+          </a:p>
+        </p:txBody>
+      </p:sp>
+      <p:sp>
+        <p:nvSpPr>
+          <p:cNvPr id="9" name="Text 7"/>
+          <p:cNvSpPr txBox="1"/>
+          <p:nvPr/>
+        </p:nvSpPr>
+        <p:spPr>
+          <a:xfrm>
+            <a:off x="822960" y="3291840"/>
+            <a:ext cx="3039770" cy="566928"/>
+          </a:xfrm>
+          <a:prstGeom prst="rect">
+            <a:avLst/>
+          </a:prstGeom>
+          <a:noFill/>
+          <a:ln/>
+        </p:spPr>
+        <p:txBody>
+          <a:bodyPr wrap="square" lIns="0" tIns="0" rIns="0" bIns="0" rtlCol="0" anchor="t"/>
+          <a:lstStyle/>
+          <a:p>
+            <a:pPr indent="0" marL="0">
+              <a:lnSpc>
+                <a:spcPts val="1350"/>
+              </a:lnSpc>
+              <a:buNone/>
+            </a:pPr>
+            <a:r>
+              <a:rPr lang="en-US" sz="1000" dirty="0">
+                <a:solidFill>
+                  <a:srgbClr val="B7C0E0"/>
+                </a:solidFill>
+                <a:latin typeface="Calibri" pitchFamily="34" charset="0"/>
+                <a:ea typeface="Calibri" pitchFamily="34" charset="-122"/>
+                <a:cs typeface="Calibri" pitchFamily="34" charset="-120"/>
+              </a:rPr>
+              <a:t>Fee: 50% of the created saving on the 30-day term, 25% on the 1-year. No savings, no fee.</a:t>
+            </a:r>
+            <a:endParaRPr lang="en-US" sz="1000" dirty="0"/>
+          </a:p>
+        </p:txBody>
+      </p:sp>
+      <p:sp>
+        <p:nvSpPr>
+          <p:cNvPr id="10" name="Text 8"/>
+          <p:cNvSpPr txBox="1"/>
+          <p:nvPr/>
+        </p:nvSpPr>
+        <p:spPr>
+          <a:xfrm>
+            <a:off x="822960" y="4023360"/>
+            <a:ext cx="1325880" cy="292608"/>
+          </a:xfrm>
+          <a:prstGeom prst="rect">
+            <a:avLst/>
+          </a:prstGeom>
+          <a:noFill/>
+          <a:ln/>
+        </p:spPr>
+        <p:txBody>
+          <a:bodyPr wrap="square" lIns="0" tIns="0" rIns="0" bIns="0" rtlCol="0" anchor="ctr"/>
+          <a:lstStyle/>
+          <a:p>
+            <a:pPr indent="0" marL="0">
+              <a:buNone/>
+            </a:pPr>
+            <a:r>
+              <a:rPr lang="en-US" sz="950" dirty="0">
+                <a:solidFill>
+                  <a:srgbClr val="AAB2D0"/>
+                </a:solidFill>
+                <a:latin typeface="Calibri" pitchFamily="34" charset="0"/>
+                <a:ea typeface="Calibri" pitchFamily="34" charset="-122"/>
+                <a:cs typeface="Calibri" pitchFamily="34" charset="-120"/>
+              </a:rPr>
+              <a:t>Pay as you go</a:t>
+            </a:r>
+            <a:endParaRPr lang="en-US" sz="950" dirty="0"/>
+          </a:p>
+        </p:txBody>
+      </p:sp>
+      <p:sp>
+        <p:nvSpPr>
+          <p:cNvPr id="11" name="Shape 9"/>
+          <p:cNvSpPr/>
+          <p:nvPr/>
+        </p:nvSpPr>
+        <p:spPr>
+          <a:xfrm>
+            <a:off x="2194560" y="4123944"/>
+            <a:ext cx="1005840" cy="91440"/>
+          </a:xfrm>
+          <a:prstGeom prst="rect">
+            <a:avLst/>
+          </a:prstGeom>
+          <a:solidFill>
+            <a:srgbClr val="1E2668"/>
+          </a:solidFill>
+          <a:ln w="3175">
+            <a:solidFill>
+              <a:srgbClr val="1E2668"/>
+            </a:solidFill>
+            <a:prstDash val="solid"/>
+          </a:ln>
+        </p:spPr>
+      </p:sp>
+      <p:sp>
+        <p:nvSpPr>
+          <p:cNvPr id="12" name="Text 10"/>
+          <p:cNvSpPr txBox="1"/>
+          <p:nvPr/>
+        </p:nvSpPr>
+        <p:spPr>
+          <a:xfrm>
+            <a:off x="3273552" y="4023360"/>
+            <a:ext cx="717194" cy="292608"/>
+          </a:xfrm>
+          <a:prstGeom prst="rect">
+            <a:avLst/>
+          </a:prstGeom>
+          <a:noFill/>
+          <a:ln/>
+        </p:spPr>
+        <p:txBody>
+          <a:bodyPr wrap="square" lIns="0" tIns="0" rIns="0" bIns="0" rtlCol="0" anchor="ctr"/>
+          <a:lstStyle/>
+          <a:p>
+            <a:pPr indent="0" marL="0">
+              <a:buNone/>
+            </a:pPr>
+            <a:r>
+              <a:rPr lang="en-US" sz="950" b="1" dirty="0">
+                <a:solidFill>
+                  <a:srgbClr val="AAB2D0"/>
+                </a:solidFill>
+                <a:latin typeface="Calibri" pitchFamily="34" charset="0"/>
+                <a:ea typeface="Calibri" pitchFamily="34" charset="-122"/>
+                <a:cs typeface="Calibri" pitchFamily="34" charset="-120"/>
+              </a:rPr>
+              <a:t>0%</a:t>
+            </a:r>
+            <a:endParaRPr lang="en-US" sz="950" dirty="0"/>
+          </a:p>
+        </p:txBody>
+      </p:sp>
+      <p:sp>
+        <p:nvSpPr>
+          <p:cNvPr id="13" name="Text 11"/>
+          <p:cNvSpPr txBox="1"/>
+          <p:nvPr/>
+        </p:nvSpPr>
+        <p:spPr>
+          <a:xfrm>
+            <a:off x="822960" y="4361688"/>
+            <a:ext cx="1325880" cy="292608"/>
+          </a:xfrm>
+          <a:prstGeom prst="rect">
+            <a:avLst/>
+          </a:prstGeom>
+          <a:noFill/>
+          <a:ln/>
+        </p:spPr>
+        <p:txBody>
+          <a:bodyPr wrap="square" lIns="0" tIns="0" rIns="0" bIns="0" rtlCol="0" anchor="ctr"/>
+          <a:lstStyle/>
+          <a:p>
+            <a:pPr indent="0" marL="0">
+              <a:buNone/>
+            </a:pPr>
+            <a:r>
+              <a:rPr lang="en-US" sz="950" b="1" dirty="0">
+                <a:solidFill>
+                  <a:srgbClr val="FFFFFF"/>
+                </a:solidFill>
+                <a:latin typeface="Calibri" pitchFamily="34" charset="0"/>
+                <a:ea typeface="Calibri" pitchFamily="34" charset="-122"/>
+                <a:cs typeface="Calibri" pitchFamily="34" charset="-120"/>
+              </a:rPr>
+              <a:t>Archera 30-day</a:t>
+            </a:r>
+            <a:endParaRPr lang="en-US" sz="950" dirty="0"/>
+          </a:p>
+        </p:txBody>
+      </p:sp>
+      <p:sp>
+        <p:nvSpPr>
+          <p:cNvPr id="14" name="Shape 12"/>
+          <p:cNvSpPr/>
+          <p:nvPr/>
+        </p:nvSpPr>
+        <p:spPr>
+          <a:xfrm>
+            <a:off x="2194560" y="4462272"/>
+            <a:ext cx="1005840" cy="91440"/>
+          </a:xfrm>
+          <a:prstGeom prst="rect">
+            <a:avLst/>
+          </a:prstGeom>
+          <a:solidFill>
+            <a:srgbClr val="1E2668"/>
+          </a:solidFill>
+          <a:ln w="3175">
+            <a:solidFill>
+              <a:srgbClr val="1E2668"/>
+            </a:solidFill>
+            <a:prstDash val="solid"/>
+          </a:ln>
+        </p:spPr>
+      </p:sp>
+      <p:sp>
+        <p:nvSpPr>
+          <p:cNvPr id="15" name="Shape 13"/>
+          <p:cNvSpPr/>
+          <p:nvPr/>
+        </p:nvSpPr>
+        <p:spPr>
+          <a:xfrm>
+            <a:off x="2194560" y="4462272"/>
+            <a:ext cx="502920" cy="91440"/>
+          </a:xfrm>
+          <a:prstGeom prst="rect">
+            <a:avLst/>
+          </a:prstGeom>
+          <a:solidFill>
+            <a:srgbClr val="0E93AE"/>
+          </a:solidFill>
+          <a:ln w="3175">
+            <a:solidFill>
+              <a:srgbClr val="0E93AE"/>
+            </a:solidFill>
+            <a:prstDash val="solid"/>
+          </a:ln>
+        </p:spPr>
+      </p:sp>
+      <p:sp>
+        <p:nvSpPr>
+          <p:cNvPr id="16" name="Text 14"/>
+          <p:cNvSpPr txBox="1"/>
+          <p:nvPr/>
+        </p:nvSpPr>
+        <p:spPr>
+          <a:xfrm>
+            <a:off x="3273552" y="4361688"/>
+            <a:ext cx="717194" cy="292608"/>
+          </a:xfrm>
+          <a:prstGeom prst="rect">
+            <a:avLst/>
+          </a:prstGeom>
+          <a:noFill/>
+          <a:ln/>
+        </p:spPr>
+        <p:txBody>
+          <a:bodyPr wrap="square" lIns="0" tIns="0" rIns="0" bIns="0" rtlCol="0" anchor="ctr"/>
+          <a:lstStyle/>
+          <a:p>
+            <a:pPr indent="0" marL="0">
+              <a:buNone/>
+            </a:pPr>
+            <a:r>
+              <a:rPr lang="en-US" sz="950" b="1" dirty="0">
+                <a:solidFill>
+                  <a:srgbClr val="0E93AE"/>
+                </a:solidFill>
+                <a:latin typeface="Calibri" pitchFamily="34" charset="0"/>
+                <a:ea typeface="Calibri" pitchFamily="34" charset="-122"/>
+                <a:cs typeface="Calibri" pitchFamily="34" charset="-120"/>
+              </a:rPr>
+              <a:t>28.5%  · exit</a:t>
+            </a:r>
+            <a:endParaRPr lang="en-US" sz="950" dirty="0"/>
+          </a:p>
+        </p:txBody>
+      </p:sp>
+      <p:sp>
+        <p:nvSpPr>
+          <p:cNvPr id="17" name="Text 15"/>
+          <p:cNvSpPr txBox="1"/>
+          <p:nvPr/>
+        </p:nvSpPr>
+        <p:spPr>
+          <a:xfrm>
+            <a:off x="822960" y="4700016"/>
+            <a:ext cx="1325880" cy="292608"/>
+          </a:xfrm>
+          <a:prstGeom prst="rect">
+            <a:avLst/>
+          </a:prstGeom>
+          <a:noFill/>
+          <a:ln/>
+        </p:spPr>
+        <p:txBody>
+          <a:bodyPr wrap="square" lIns="0" tIns="0" rIns="0" bIns="0" rtlCol="0" anchor="ctr"/>
+          <a:lstStyle/>
+          <a:p>
+            <a:pPr indent="0" marL="0">
+              <a:buNone/>
+            </a:pPr>
+            <a:r>
+              <a:rPr lang="en-US" sz="950" dirty="0">
+                <a:solidFill>
+                  <a:srgbClr val="AAB2D0"/>
+                </a:solidFill>
+                <a:latin typeface="Calibri" pitchFamily="34" charset="0"/>
+                <a:ea typeface="Calibri" pitchFamily="34" charset="-122"/>
+                <a:cs typeface="Calibri" pitchFamily="34" charset="-120"/>
+              </a:rPr>
+              <a:t>Native 1-year</a:t>
+            </a:r>
+            <a:endParaRPr lang="en-US" sz="950" dirty="0"/>
+          </a:p>
+        </p:txBody>
+      </p:sp>
+      <p:sp>
+        <p:nvSpPr>
+          <p:cNvPr id="18" name="Shape 16"/>
+          <p:cNvSpPr/>
+          <p:nvPr/>
+        </p:nvSpPr>
+        <p:spPr>
+          <a:xfrm>
+            <a:off x="2194560" y="4800600"/>
+            <a:ext cx="1005840" cy="91440"/>
+          </a:xfrm>
+          <a:prstGeom prst="rect">
+            <a:avLst/>
+          </a:prstGeom>
+          <a:solidFill>
+            <a:srgbClr val="1E2668"/>
+          </a:solidFill>
+          <a:ln w="3175">
+            <a:solidFill>
+              <a:srgbClr val="1E2668"/>
+            </a:solidFill>
+            <a:prstDash val="solid"/>
+          </a:ln>
+        </p:spPr>
+      </p:sp>
+      <p:sp>
+        <p:nvSpPr>
+          <p:cNvPr id="19" name="Shape 17"/>
+          <p:cNvSpPr/>
+          <p:nvPr/>
+        </p:nvSpPr>
+        <p:spPr>
+          <a:xfrm>
+            <a:off x="2194560" y="4800600"/>
+            <a:ext cx="635267" cy="91440"/>
+          </a:xfrm>
+          <a:prstGeom prst="rect">
+            <a:avLst/>
+          </a:prstGeom>
+          <a:solidFill>
+            <a:srgbClr val="5B6486"/>
+          </a:solidFill>
+          <a:ln w="3175">
+            <a:solidFill>
+              <a:srgbClr val="5B6486"/>
+            </a:solidFill>
+            <a:prstDash val="solid"/>
+          </a:ln>
+        </p:spPr>
+      </p:sp>
+      <p:sp>
+        <p:nvSpPr>
+          <p:cNvPr id="20" name="Text 18"/>
+          <p:cNvSpPr txBox="1"/>
+          <p:nvPr/>
+        </p:nvSpPr>
+        <p:spPr>
+          <a:xfrm>
+            <a:off x="3273552" y="4700016"/>
+            <a:ext cx="717194" cy="292608"/>
+          </a:xfrm>
+          <a:prstGeom prst="rect">
+            <a:avLst/>
+          </a:prstGeom>
+          <a:noFill/>
+          <a:ln/>
+        </p:spPr>
+        <p:txBody>
+          <a:bodyPr wrap="square" lIns="0" tIns="0" rIns="0" bIns="0" rtlCol="0" anchor="ctr"/>
+          <a:lstStyle/>
+          <a:p>
+            <a:pPr indent="0" marL="0">
+              <a:buNone/>
+            </a:pPr>
+            <a:r>
+              <a:rPr lang="en-US" sz="950" b="1" dirty="0">
+                <a:solidFill>
+                  <a:srgbClr val="AAB2D0"/>
+                </a:solidFill>
+                <a:latin typeface="Calibri" pitchFamily="34" charset="0"/>
+                <a:ea typeface="Calibri" pitchFamily="34" charset="-122"/>
+                <a:cs typeface="Calibri" pitchFamily="34" charset="-120"/>
+              </a:rPr>
+              <a:t>36%</a:t>
+            </a:r>
+            <a:endParaRPr lang="en-US" sz="950" dirty="0"/>
+          </a:p>
+        </p:txBody>
+      </p:sp>
+      <p:sp>
+        <p:nvSpPr>
+          <p:cNvPr id="21" name="Text 19"/>
+          <p:cNvSpPr txBox="1"/>
+          <p:nvPr/>
+        </p:nvSpPr>
+        <p:spPr>
+          <a:xfrm>
+            <a:off x="822960" y="5038344"/>
+            <a:ext cx="1325880" cy="292608"/>
+          </a:xfrm>
+          <a:prstGeom prst="rect">
+            <a:avLst/>
+          </a:prstGeom>
+          <a:noFill/>
+          <a:ln/>
+        </p:spPr>
+        <p:txBody>
+          <a:bodyPr wrap="square" lIns="0" tIns="0" rIns="0" bIns="0" rtlCol="0" anchor="ctr"/>
+          <a:lstStyle/>
+          <a:p>
+            <a:pPr indent="0" marL="0">
+              <a:buNone/>
+            </a:pPr>
+            <a:r>
+              <a:rPr lang="en-US" sz="950" b="1" dirty="0">
+                <a:solidFill>
+                  <a:srgbClr val="FFFFFF"/>
+                </a:solidFill>
+                <a:latin typeface="Calibri" pitchFamily="34" charset="0"/>
+                <a:ea typeface="Calibri" pitchFamily="34" charset="-122"/>
+                <a:cs typeface="Calibri" pitchFamily="34" charset="-120"/>
+              </a:rPr>
+              <a:t>Archera 1-year</a:t>
+            </a:r>
+            <a:endParaRPr lang="en-US" sz="950" dirty="0"/>
+          </a:p>
+        </p:txBody>
+      </p:sp>
+      <p:sp>
+        <p:nvSpPr>
+          <p:cNvPr id="22" name="Shape 20"/>
+          <p:cNvSpPr/>
+          <p:nvPr/>
+        </p:nvSpPr>
+        <p:spPr>
+          <a:xfrm>
+            <a:off x="2194560" y="5138928"/>
+            <a:ext cx="1005840" cy="91440"/>
+          </a:xfrm>
+          <a:prstGeom prst="rect">
+            <a:avLst/>
+          </a:prstGeom>
+          <a:solidFill>
+            <a:srgbClr val="1E2668"/>
+          </a:solidFill>
+          <a:ln w="3175">
+            <a:solidFill>
+              <a:srgbClr val="1E2668"/>
+            </a:solidFill>
+            <a:prstDash val="solid"/>
+          </a:ln>
+        </p:spPr>
+      </p:sp>
+      <p:sp>
+        <p:nvSpPr>
+          <p:cNvPr id="23" name="Shape 21"/>
+          <p:cNvSpPr/>
+          <p:nvPr/>
+        </p:nvSpPr>
+        <p:spPr>
+          <a:xfrm>
+            <a:off x="2194560" y="5138928"/>
+            <a:ext cx="754380" cy="91440"/>
+          </a:xfrm>
+          <a:prstGeom prst="rect">
+            <a:avLst/>
+          </a:prstGeom>
+          <a:solidFill>
+            <a:srgbClr val="5566D8"/>
+          </a:solidFill>
+          <a:ln w="3175">
+            <a:solidFill>
+              <a:srgbClr val="5566D8"/>
+            </a:solidFill>
+            <a:prstDash val="solid"/>
+          </a:ln>
+        </p:spPr>
+      </p:sp>
+      <p:sp>
+        <p:nvSpPr>
+          <p:cNvPr id="24" name="Text 22"/>
+          <p:cNvSpPr txBox="1"/>
+          <p:nvPr/>
+        </p:nvSpPr>
+        <p:spPr>
+          <a:xfrm>
+            <a:off x="3273552" y="5038344"/>
+            <a:ext cx="717194" cy="292608"/>
+          </a:xfrm>
+          <a:prstGeom prst="rect">
+            <a:avLst/>
+          </a:prstGeom>
+          <a:noFill/>
+          <a:ln/>
+        </p:spPr>
+        <p:txBody>
+          <a:bodyPr wrap="square" lIns="0" tIns="0" rIns="0" bIns="0" rtlCol="0" anchor="ctr"/>
+          <a:lstStyle/>
+          <a:p>
+            <a:pPr indent="0" marL="0">
+              <a:buNone/>
+            </a:pPr>
+            <a:r>
+              <a:rPr lang="en-US" sz="950" b="1" dirty="0">
+                <a:solidFill>
+                  <a:srgbClr val="5566D8"/>
+                </a:solidFill>
+                <a:latin typeface="Calibri" pitchFamily="34" charset="0"/>
+                <a:ea typeface="Calibri" pitchFamily="34" charset="-122"/>
+                <a:cs typeface="Calibri" pitchFamily="34" charset="-120"/>
+              </a:rPr>
+              <a:t>42.75%  · exit</a:t>
+            </a:r>
+            <a:endParaRPr lang="en-US" sz="950" dirty="0"/>
+          </a:p>
+        </p:txBody>
+      </p:sp>
+      <p:sp>
+        <p:nvSpPr>
+          <p:cNvPr id="25" name="Text 23"/>
+          <p:cNvSpPr txBox="1"/>
+          <p:nvPr/>
+        </p:nvSpPr>
+        <p:spPr>
+          <a:xfrm>
+            <a:off x="822960" y="5376672"/>
+            <a:ext cx="1325880" cy="292608"/>
+          </a:xfrm>
+          <a:prstGeom prst="rect">
+            <a:avLst/>
+          </a:prstGeom>
+          <a:noFill/>
+          <a:ln/>
+        </p:spPr>
+        <p:txBody>
+          <a:bodyPr wrap="square" lIns="0" tIns="0" rIns="0" bIns="0" rtlCol="0" anchor="ctr"/>
+          <a:lstStyle/>
+          <a:p>
+            <a:pPr indent="0" marL="0">
+              <a:buNone/>
+            </a:pPr>
+            <a:r>
+              <a:rPr lang="en-US" sz="950" dirty="0">
+                <a:solidFill>
+                  <a:srgbClr val="AAB2D0"/>
+                </a:solidFill>
+                <a:latin typeface="Calibri" pitchFamily="34" charset="0"/>
+                <a:ea typeface="Calibri" pitchFamily="34" charset="-122"/>
+                <a:cs typeface="Calibri" pitchFamily="34" charset="-120"/>
+              </a:rPr>
+              <a:t>Native 3-year</a:t>
+            </a:r>
+            <a:endParaRPr lang="en-US" sz="950" dirty="0"/>
+          </a:p>
+        </p:txBody>
+      </p:sp>
+      <p:sp>
+        <p:nvSpPr>
+          <p:cNvPr id="26" name="Shape 24"/>
+          <p:cNvSpPr/>
+          <p:nvPr/>
+        </p:nvSpPr>
+        <p:spPr>
+          <a:xfrm>
+            <a:off x="2194560" y="5477256"/>
+            <a:ext cx="1005840" cy="91440"/>
+          </a:xfrm>
+          <a:prstGeom prst="rect">
+            <a:avLst/>
+          </a:prstGeom>
+          <a:solidFill>
+            <a:srgbClr val="1E2668"/>
+          </a:solidFill>
+          <a:ln w="3175">
+            <a:solidFill>
+              <a:srgbClr val="1E2668"/>
+            </a:solidFill>
+            <a:prstDash val="solid"/>
+          </a:ln>
+        </p:spPr>
+      </p:sp>
+      <p:sp>
+        <p:nvSpPr>
+          <p:cNvPr id="27" name="Shape 25"/>
+          <p:cNvSpPr/>
+          <p:nvPr/>
+        </p:nvSpPr>
+        <p:spPr>
+          <a:xfrm>
+            <a:off x="2194560" y="5477256"/>
+            <a:ext cx="1005840" cy="91440"/>
+          </a:xfrm>
+          <a:prstGeom prst="rect">
+            <a:avLst/>
+          </a:prstGeom>
+          <a:solidFill>
+            <a:srgbClr val="8E96C8"/>
+          </a:solidFill>
+          <a:ln w="3175">
+            <a:solidFill>
+              <a:srgbClr val="8E96C8"/>
+            </a:solidFill>
+            <a:prstDash val="solid"/>
+          </a:ln>
+        </p:spPr>
+      </p:sp>
+      <p:sp>
+        <p:nvSpPr>
+          <p:cNvPr id="28" name="Text 26"/>
+          <p:cNvSpPr txBox="1"/>
+          <p:nvPr/>
+        </p:nvSpPr>
+        <p:spPr>
+          <a:xfrm>
+            <a:off x="3273552" y="5376672"/>
+            <a:ext cx="717194" cy="292608"/>
+          </a:xfrm>
+          <a:prstGeom prst="rect">
+            <a:avLst/>
+          </a:prstGeom>
+          <a:noFill/>
+          <a:ln/>
+        </p:spPr>
+        <p:txBody>
+          <a:bodyPr wrap="square" lIns="0" tIns="0" rIns="0" bIns="0" rtlCol="0" anchor="ctr"/>
+          <a:lstStyle/>
+          <a:p>
+            <a:pPr indent="0" marL="0">
+              <a:buNone/>
+            </a:pPr>
+            <a:r>
+              <a:rPr lang="en-US" sz="950" b="1" dirty="0">
+                <a:solidFill>
+                  <a:srgbClr val="AAB2D0"/>
+                </a:solidFill>
+                <a:latin typeface="Calibri" pitchFamily="34" charset="0"/>
+                <a:ea typeface="Calibri" pitchFamily="34" charset="-122"/>
+                <a:cs typeface="Calibri" pitchFamily="34" charset="-120"/>
+              </a:rPr>
+              <a:t>57%</a:t>
+            </a:r>
+            <a:endParaRPr lang="en-US" sz="950" dirty="0"/>
+          </a:p>
+        </p:txBody>
+      </p:sp>
+      <p:sp>
+        <p:nvSpPr>
+          <p:cNvPr id="29" name="Shape 27"/>
+          <p:cNvSpPr/>
+          <p:nvPr/>
+        </p:nvSpPr>
+        <p:spPr>
+          <a:xfrm>
+            <a:off x="4319930" y="1627632"/>
+            <a:ext cx="3551834" cy="4169664"/>
+          </a:xfrm>
+          <a:prstGeom prst="roundRect">
+            <a:avLst>
+              <a:gd name="adj" fmla="val 1802"/>
+            </a:avLst>
+          </a:prstGeom>
+          <a:solidFill>
+            <a:srgbClr val="141A4F"/>
+          </a:solidFill>
+          <a:ln w="9525">
+            <a:solidFill>
+              <a:srgbClr val="3D4569"/>
+            </a:solidFill>
+            <a:prstDash val="solid"/>
+          </a:ln>
+        </p:spPr>
+      </p:sp>
+      <p:sp>
+        <p:nvSpPr>
+          <p:cNvPr id="30" name="Text 28"/>
+          <p:cNvSpPr txBox="1"/>
+          <p:nvPr/>
+        </p:nvSpPr>
+        <p:spPr>
+          <a:xfrm>
+            <a:off x="4575962" y="1810512"/>
+            <a:ext cx="3039770" cy="201168"/>
+          </a:xfrm>
+          <a:prstGeom prst="rect">
+            <a:avLst/>
+          </a:prstGeom>
+          <a:noFill/>
+          <a:ln/>
+        </p:spPr>
+        <p:txBody>
+          <a:bodyPr wrap="square" lIns="0" tIns="0" rIns="0" bIns="0" rtlCol="0" anchor="ctr"/>
+          <a:lstStyle/>
+          <a:p>
+            <a:pPr indent="0" marL="0">
+              <a:buNone/>
+            </a:pPr>
+            <a:r>
+              <a:rPr lang="en-US" sz="900" b="1" spc="200" kern="0" dirty="0">
+                <a:solidFill>
+                  <a:srgbClr val="F5A623"/>
+                </a:solidFill>
+                <a:latin typeface="Calibri" pitchFamily="34" charset="0"/>
+                <a:ea typeface="Calibri" pitchFamily="34" charset="-122"/>
+                <a:cs typeface="Calibri" pitchFamily="34" charset="-120"/>
+              </a:rPr>
+              <a:t>WHEN NOT TO — AND THE FINE PRINT</a:t>
+            </a:r>
+            <a:endParaRPr lang="en-US" sz="900" dirty="0"/>
+          </a:p>
+        </p:txBody>
+      </p:sp>
+      <p:sp>
+        <p:nvSpPr>
+          <p:cNvPr id="31" name="Text 29"/>
+          <p:cNvSpPr txBox="1"/>
+          <p:nvPr/>
+        </p:nvSpPr>
+        <p:spPr>
+          <a:xfrm>
+            <a:off x="4575962" y="2103120"/>
+            <a:ext cx="3039770" cy="237744"/>
+          </a:xfrm>
+          <a:prstGeom prst="rect">
+            <a:avLst/>
+          </a:prstGeom>
+          <a:noFill/>
+          <a:ln/>
+        </p:spPr>
+        <p:txBody>
+          <a:bodyPr wrap="square" lIns="0" tIns="0" rIns="0" bIns="0" rtlCol="0" anchor="ctr"/>
+          <a:lstStyle/>
+          <a:p>
+            <a:pPr indent="0" marL="0">
+              <a:buNone/>
+            </a:pPr>
+            <a:r>
+              <a:rPr lang="en-US" sz="1050" b="1" dirty="0">
+                <a:solidFill>
+                  <a:srgbClr val="FFFFFF"/>
+                </a:solidFill>
+                <a:latin typeface="Calibri" pitchFamily="34" charset="0"/>
+                <a:ea typeface="Calibri" pitchFamily="34" charset="-122"/>
+                <a:cs typeface="Calibri" pitchFamily="34" charset="-120"/>
+              </a:rPr>
+              <a:t>Stable three-year workloads</a:t>
+            </a:r>
+            <a:endParaRPr lang="en-US" sz="1050" dirty="0"/>
+          </a:p>
+        </p:txBody>
+      </p:sp>
+      <p:sp>
+        <p:nvSpPr>
+          <p:cNvPr id="32" name="Text 30"/>
+          <p:cNvSpPr txBox="1"/>
+          <p:nvPr/>
+        </p:nvSpPr>
+        <p:spPr>
+          <a:xfrm>
+            <a:off x="4575962" y="2350008"/>
+            <a:ext cx="3039770" cy="566928"/>
+          </a:xfrm>
+          <a:prstGeom prst="rect">
+            <a:avLst/>
+          </a:prstGeom>
+          <a:noFill/>
+          <a:ln/>
+        </p:spPr>
+        <p:txBody>
+          <a:bodyPr wrap="square" lIns="0" tIns="0" rIns="0" bIns="0" rtlCol="0" anchor="t"/>
+          <a:lstStyle/>
+          <a:p>
+            <a:pPr indent="0" marL="0">
+              <a:lnSpc>
+                <a:spcPts val="1300"/>
+              </a:lnSpc>
+              <a:buNone/>
+            </a:pPr>
+            <a:r>
+              <a:rPr lang="en-US" sz="950" dirty="0">
+                <a:solidFill>
+                  <a:srgbClr val="B7C0E0"/>
+                </a:solidFill>
+                <a:latin typeface="Calibri" pitchFamily="34" charset="0"/>
+                <a:ea typeface="Calibri" pitchFamily="34" charset="-122"/>
+                <a:cs typeface="Calibri" pitchFamily="34" charset="-120"/>
+              </a:rPr>
+              <a:t>Buy the native 3-year and keep all 57%. Archera is only for the spend that cannot honestly be committed.</a:t>
+            </a:r>
+            <a:endParaRPr lang="en-US" sz="950" dirty="0"/>
+          </a:p>
+        </p:txBody>
+      </p:sp>
+      <p:sp>
+        <p:nvSpPr>
+          <p:cNvPr id="33" name="Text 31"/>
+          <p:cNvSpPr txBox="1"/>
+          <p:nvPr/>
+        </p:nvSpPr>
+        <p:spPr>
+          <a:xfrm>
+            <a:off x="4575962" y="2999232"/>
+            <a:ext cx="3039770" cy="237744"/>
+          </a:xfrm>
+          <a:prstGeom prst="rect">
+            <a:avLst/>
+          </a:prstGeom>
+          <a:noFill/>
+          <a:ln/>
+        </p:spPr>
+        <p:txBody>
+          <a:bodyPr wrap="square" lIns="0" tIns="0" rIns="0" bIns="0" rtlCol="0" anchor="ctr"/>
+          <a:lstStyle/>
+          <a:p>
+            <a:pPr indent="0" marL="0">
+              <a:buNone/>
+            </a:pPr>
+            <a:r>
+              <a:rPr lang="en-US" sz="1050" b="1" dirty="0">
+                <a:solidFill>
+                  <a:srgbClr val="FFFFFF"/>
+                </a:solidFill>
+                <a:latin typeface="Calibri" pitchFamily="34" charset="0"/>
+                <a:ea typeface="Calibri" pitchFamily="34" charset="-122"/>
+                <a:cs typeface="Calibri" pitchFamily="34" charset="-120"/>
+              </a:rPr>
+              <a:t>Rebate cover is off by default</a:t>
+            </a:r>
+            <a:endParaRPr lang="en-US" sz="1050" dirty="0"/>
+          </a:p>
+        </p:txBody>
+      </p:sp>
+      <p:sp>
+        <p:nvSpPr>
+          <p:cNvPr id="34" name="Text 32"/>
+          <p:cNvSpPr txBox="1"/>
+          <p:nvPr/>
+        </p:nvSpPr>
+        <p:spPr>
+          <a:xfrm>
+            <a:off x="4575962" y="3246120"/>
+            <a:ext cx="3039770" cy="566928"/>
+          </a:xfrm>
+          <a:prstGeom prst="rect">
+            <a:avLst/>
+          </a:prstGeom>
+          <a:noFill/>
+          <a:ln/>
+        </p:spPr>
+        <p:txBody>
+          <a:bodyPr wrap="square" lIns="0" tIns="0" rIns="0" bIns="0" rtlCol="0" anchor="t"/>
+          <a:lstStyle/>
+          <a:p>
+            <a:pPr indent="0" marL="0">
+              <a:lnSpc>
+                <a:spcPts val="1300"/>
+              </a:lnSpc>
+              <a:buNone/>
+            </a:pPr>
+            <a:r>
+              <a:rPr lang="en-US" sz="950" dirty="0">
+                <a:solidFill>
+                  <a:srgbClr val="B7C0E0"/>
+                </a:solidFill>
+                <a:latin typeface="Calibri" pitchFamily="34" charset="0"/>
+                <a:ea typeface="Calibri" pitchFamily="34" charset="-122"/>
+                <a:cs typeface="Calibri" pitchFamily="34" charset="-120"/>
+              </a:rPr>
+              <a:t>It must be switched on with Archera — release-only cover is not rebate cover.</a:t>
+            </a:r>
+            <a:endParaRPr lang="en-US" sz="950" dirty="0"/>
+          </a:p>
+        </p:txBody>
+      </p:sp>
+      <p:sp>
+        <p:nvSpPr>
+          <p:cNvPr id="35" name="Text 33"/>
+          <p:cNvSpPr txBox="1"/>
+          <p:nvPr/>
+        </p:nvSpPr>
+        <p:spPr>
+          <a:xfrm>
+            <a:off x="4575962" y="3895344"/>
+            <a:ext cx="3039770" cy="237744"/>
+          </a:xfrm>
+          <a:prstGeom prst="rect">
+            <a:avLst/>
+          </a:prstGeom>
+          <a:noFill/>
+          <a:ln/>
+        </p:spPr>
+        <p:txBody>
+          <a:bodyPr wrap="square" lIns="0" tIns="0" rIns="0" bIns="0" rtlCol="0" anchor="ctr"/>
+          <a:lstStyle/>
+          <a:p>
+            <a:pPr indent="0" marL="0">
+              <a:buNone/>
+            </a:pPr>
+            <a:r>
+              <a:rPr lang="en-US" sz="1050" b="1" dirty="0">
+                <a:solidFill>
+                  <a:srgbClr val="FFFFFF"/>
+                </a:solidFill>
+                <a:latin typeface="Calibri" pitchFamily="34" charset="0"/>
+                <a:ea typeface="Calibri" pitchFamily="34" charset="-122"/>
+                <a:cs typeface="Calibri" pitchFamily="34" charset="-120"/>
+              </a:rPr>
+              <a:t>Buybacks are filed, not automatic</a:t>
+            </a:r>
+            <a:endParaRPr lang="en-US" sz="1050" dirty="0"/>
+          </a:p>
+        </p:txBody>
+      </p:sp>
+      <p:sp>
+        <p:nvSpPr>
+          <p:cNvPr id="36" name="Text 34"/>
+          <p:cNvSpPr txBox="1"/>
+          <p:nvPr/>
+        </p:nvSpPr>
+        <p:spPr>
+          <a:xfrm>
+            <a:off x="4575962" y="4142232"/>
+            <a:ext cx="3039770" cy="566928"/>
+          </a:xfrm>
+          <a:prstGeom prst="rect">
+            <a:avLst/>
+          </a:prstGeom>
+          <a:noFill/>
+          <a:ln/>
+        </p:spPr>
+        <p:txBody>
+          <a:bodyPr wrap="square" lIns="0" tIns="0" rIns="0" bIns="0" rtlCol="0" anchor="t"/>
+          <a:lstStyle/>
+          <a:p>
+            <a:pPr indent="0" marL="0">
+              <a:lnSpc>
+                <a:spcPts val="1300"/>
+              </a:lnSpc>
+              <a:buNone/>
+            </a:pPr>
+            <a:r>
+              <a:rPr lang="en-US" sz="950" dirty="0">
+                <a:solidFill>
+                  <a:srgbClr val="B7C0E0"/>
+                </a:solidFill>
+                <a:latin typeface="Calibri" pitchFamily="34" charset="0"/>
+                <a:ea typeface="Calibri" pitchFamily="34" charset="-122"/>
+                <a:cs typeface="Calibri" pitchFamily="34" charset="-120"/>
+              </a:rPr>
+              <a:t>Somebody requests the release, and EC2 buybacks need the RI Marketplace enabled first.</a:t>
+            </a:r>
+            <a:endParaRPr lang="en-US" sz="950" dirty="0"/>
+          </a:p>
+        </p:txBody>
+      </p:sp>
+      <p:sp>
+        <p:nvSpPr>
+          <p:cNvPr id="37" name="Text 35"/>
+          <p:cNvSpPr txBox="1"/>
+          <p:nvPr/>
+        </p:nvSpPr>
+        <p:spPr>
+          <a:xfrm>
+            <a:off x="4575962" y="4791456"/>
+            <a:ext cx="3039770" cy="237744"/>
+          </a:xfrm>
+          <a:prstGeom prst="rect">
+            <a:avLst/>
+          </a:prstGeom>
+          <a:noFill/>
+          <a:ln/>
+        </p:spPr>
+        <p:txBody>
+          <a:bodyPr wrap="square" lIns="0" tIns="0" rIns="0" bIns="0" rtlCol="0" anchor="ctr"/>
+          <a:lstStyle/>
+          <a:p>
+            <a:pPr indent="0" marL="0">
+              <a:buNone/>
+            </a:pPr>
+            <a:r>
+              <a:rPr lang="en-US" sz="1050" b="1" dirty="0">
+                <a:solidFill>
+                  <a:srgbClr val="FFFFFF"/>
+                </a:solidFill>
+                <a:latin typeface="Calibri" pitchFamily="34" charset="0"/>
+                <a:ea typeface="Calibri" pitchFamily="34" charset="-122"/>
+                <a:cs typeface="Calibri" pitchFamily="34" charset="-120"/>
+              </a:rPr>
+              <a:t>The guarantees are contractual</a:t>
+            </a:r>
+            <a:endParaRPr lang="en-US" sz="1050" dirty="0"/>
+          </a:p>
+        </p:txBody>
+      </p:sp>
+      <p:sp>
+        <p:nvSpPr>
+          <p:cNvPr id="38" name="Text 36"/>
+          <p:cNvSpPr txBox="1"/>
+          <p:nvPr/>
+        </p:nvSpPr>
+        <p:spPr>
+          <a:xfrm>
+            <a:off x="4575962" y="5038344"/>
+            <a:ext cx="3039770" cy="566928"/>
+          </a:xfrm>
+          <a:prstGeom prst="rect">
+            <a:avLst/>
+          </a:prstGeom>
+          <a:noFill/>
+          <a:ln/>
+        </p:spPr>
+        <p:txBody>
+          <a:bodyPr wrap="square" lIns="0" tIns="0" rIns="0" bIns="0" rtlCol="0" anchor="t"/>
+          <a:lstStyle/>
+          <a:p>
+            <a:pPr indent="0" marL="0">
+              <a:lnSpc>
+                <a:spcPts val="1300"/>
+              </a:lnSpc>
+              <a:buNone/>
+            </a:pPr>
+            <a:r>
+              <a:rPr lang="en-US" sz="950" dirty="0">
+                <a:solidFill>
+                  <a:srgbClr val="B7C0E0"/>
+                </a:solidFill>
+                <a:latin typeface="Calibri" pitchFamily="34" charset="0"/>
+                <a:ea typeface="Calibri" pitchFamily="34" charset="-122"/>
+                <a:cs typeface="Calibri" pitchFamily="34" charset="-120"/>
+              </a:rPr>
+              <a:t>Backed by third-party reinsurance — not a regulated insurance policy.</a:t>
+            </a:r>
+            <a:endParaRPr lang="en-US" sz="950" dirty="0"/>
+          </a:p>
+        </p:txBody>
+      </p:sp>
+      <p:sp>
+        <p:nvSpPr>
+          <p:cNvPr id="39" name="Shape 37"/>
+          <p:cNvSpPr/>
+          <p:nvPr/>
+        </p:nvSpPr>
+        <p:spPr>
+          <a:xfrm>
+            <a:off x="8072933" y="1627632"/>
+            <a:ext cx="3551834" cy="4169664"/>
+          </a:xfrm>
+          <a:prstGeom prst="roundRect">
+            <a:avLst>
+              <a:gd name="adj" fmla="val 1802"/>
+            </a:avLst>
+          </a:prstGeom>
+          <a:solidFill>
+            <a:srgbClr val="1E2668"/>
+          </a:solidFill>
+          <a:ln w="13970">
+            <a:solidFill>
+              <a:srgbClr val="3B4CC0"/>
+            </a:solidFill>
+            <a:prstDash val="solid"/>
+          </a:ln>
+        </p:spPr>
+      </p:sp>
+      <p:sp>
+        <p:nvSpPr>
+          <p:cNvPr id="40" name="Text 38"/>
+          <p:cNvSpPr txBox="1"/>
+          <p:nvPr/>
+        </p:nvSpPr>
+        <p:spPr>
+          <a:xfrm>
+            <a:off x="8328965" y="1810512"/>
+            <a:ext cx="3039770" cy="201168"/>
+          </a:xfrm>
+          <a:prstGeom prst="rect">
+            <a:avLst/>
+          </a:prstGeom>
+          <a:noFill/>
+          <a:ln/>
+        </p:spPr>
+        <p:txBody>
+          <a:bodyPr wrap="square" lIns="0" tIns="0" rIns="0" bIns="0" rtlCol="0" anchor="ctr"/>
+          <a:lstStyle/>
+          <a:p>
+            <a:pPr indent="0" marL="0">
+              <a:buNone/>
+            </a:pPr>
+            <a:r>
+              <a:rPr lang="en-US" sz="900" b="1" spc="200" kern="0" dirty="0">
+                <a:solidFill>
+                  <a:srgbClr val="19C6E6"/>
+                </a:solidFill>
+                <a:latin typeface="Calibri" pitchFamily="34" charset="0"/>
+                <a:ea typeface="Calibri" pitchFamily="34" charset="-122"/>
+                <a:cs typeface="Calibri" pitchFamily="34" charset="-120"/>
+              </a:rPr>
+              <a:t>THE PARTNERSHIP</a:t>
+            </a:r>
+            <a:endParaRPr lang="en-US" sz="900" dirty="0"/>
+          </a:p>
+        </p:txBody>
+      </p:sp>
+      <p:sp>
+        <p:nvSpPr>
+          <p:cNvPr id="41" name="Text 39"/>
+          <p:cNvSpPr txBox="1"/>
+          <p:nvPr/>
+        </p:nvSpPr>
+        <p:spPr>
+          <a:xfrm>
+            <a:off x="8328965" y="2084832"/>
+            <a:ext cx="3039770" cy="658368"/>
+          </a:xfrm>
+          <a:prstGeom prst="rect">
+            <a:avLst/>
+          </a:prstGeom>
+          <a:noFill/>
+          <a:ln/>
+        </p:spPr>
+        <p:txBody>
+          <a:bodyPr wrap="square" lIns="0" tIns="0" rIns="0" bIns="0" rtlCol="0" anchor="t"/>
+          <a:lstStyle/>
+          <a:p>
+            <a:pPr indent="0" marL="0">
+              <a:lnSpc>
+                <a:spcPts val="1350"/>
+              </a:lnSpc>
+              <a:buNone/>
+            </a:pPr>
+            <a:r>
+              <a:rPr lang="en-US" sz="1000" dirty="0">
+                <a:solidFill>
+                  <a:srgbClr val="B7C0E0"/>
+                </a:solidFill>
+                <a:latin typeface="Calibri" pitchFamily="34" charset="0"/>
+                <a:ea typeface="Calibri" pitchFamily="34" charset="-122"/>
+                <a:cs typeface="Calibri" pitchFamily="34" charset="-120"/>
+              </a:rPr>
+              <a:t>The platform is free; the premium meters monthly on savings realised, billed through AWS Marketplace CPPO.</a:t>
+            </a:r>
+            <a:endParaRPr lang="en-US" sz="1000" dirty="0"/>
+          </a:p>
+        </p:txBody>
+      </p:sp>
+      <p:sp>
+        <p:nvSpPr>
+          <p:cNvPr id="42" name="Text 40"/>
+          <p:cNvSpPr txBox="1"/>
+          <p:nvPr/>
+        </p:nvSpPr>
+        <p:spPr>
+          <a:xfrm>
+            <a:off x="8328965" y="2779776"/>
+            <a:ext cx="3039770" cy="658368"/>
+          </a:xfrm>
+          <a:prstGeom prst="rect">
+            <a:avLst/>
+          </a:prstGeom>
+          <a:noFill/>
+          <a:ln/>
+        </p:spPr>
+        <p:txBody>
+          <a:bodyPr wrap="square" lIns="0" tIns="0" rIns="0" bIns="0" rtlCol="0" anchor="t"/>
+          <a:lstStyle/>
+          <a:p>
+            <a:pPr indent="0" marL="0">
+              <a:lnSpc>
+                <a:spcPts val="1350"/>
+              </a:lnSpc>
+              <a:buNone/>
+            </a:pPr>
+            <a:r>
+              <a:rPr lang="en-US" sz="1000" dirty="0">
+                <a:solidFill>
+                  <a:srgbClr val="B7C0E0"/>
+                </a:solidFill>
+                <a:latin typeface="Calibri" pitchFamily="34" charset="0"/>
+                <a:ea typeface="Calibri" pitchFamily="34" charset="-122"/>
+                <a:cs typeface="Calibri" pitchFamily="34" charset="-120"/>
+              </a:rPr>
+              <a:t>Co-Seller rev-share: 20% / 25% / 30% by commitment MRR — on entities net-new to Archera only.</a:t>
+            </a:r>
+            <a:endParaRPr lang="en-US" sz="1000" dirty="0"/>
+          </a:p>
+        </p:txBody>
+      </p:sp>
+      <p:sp>
+        <p:nvSpPr>
+          <p:cNvPr id="43" name="Text 41"/>
+          <p:cNvSpPr txBox="1"/>
+          <p:nvPr/>
+        </p:nvSpPr>
+        <p:spPr>
+          <a:xfrm>
+            <a:off x="8328965" y="3584448"/>
+            <a:ext cx="3039770" cy="201168"/>
+          </a:xfrm>
+          <a:prstGeom prst="rect">
+            <a:avLst/>
+          </a:prstGeom>
+          <a:noFill/>
+          <a:ln/>
+        </p:spPr>
+        <p:txBody>
+          <a:bodyPr wrap="square" lIns="0" tIns="0" rIns="0" bIns="0" rtlCol="0" anchor="ctr"/>
+          <a:lstStyle/>
+          <a:p>
+            <a:pPr indent="0" marL="0">
+              <a:buNone/>
+            </a:pPr>
+            <a:r>
+              <a:rPr lang="en-US" sz="850" b="1" spc="200" kern="0" dirty="0">
+                <a:solidFill>
+                  <a:srgbClr val="8E96C8"/>
+                </a:solidFill>
+                <a:latin typeface="Calibri" pitchFamily="34" charset="0"/>
+                <a:ea typeface="Calibri" pitchFamily="34" charset="-122"/>
+                <a:cs typeface="Calibri" pitchFamily="34" charset="-120"/>
+              </a:rPr>
+              <a:t>THE THREE ASKS</a:t>
+            </a:r>
+            <a:endParaRPr lang="en-US" sz="850" dirty="0"/>
+          </a:p>
+        </p:txBody>
+      </p:sp>
+      <p:sp>
+        <p:nvSpPr>
+          <p:cNvPr id="44" name="Shape 42"/>
+          <p:cNvSpPr/>
+          <p:nvPr/>
+        </p:nvSpPr>
+        <p:spPr>
+          <a:xfrm>
+            <a:off x="8347253" y="3941064"/>
+            <a:ext cx="274320" cy="274320"/>
+          </a:xfrm>
+          <a:prstGeom prst="ellipse">
+            <a:avLst/>
+          </a:prstGeom>
+          <a:solidFill>
+            <a:srgbClr val="3B4CC0"/>
+          </a:solidFill>
+          <a:ln w="9525">
+            <a:solidFill>
+              <a:srgbClr val="5566D8"/>
+            </a:solidFill>
+            <a:prstDash val="solid"/>
+          </a:ln>
+        </p:spPr>
+      </p:sp>
+      <p:sp>
+        <p:nvSpPr>
+          <p:cNvPr id="45" name="Text 43"/>
+          <p:cNvSpPr txBox="1"/>
+          <p:nvPr/>
+        </p:nvSpPr>
+        <p:spPr>
+          <a:xfrm>
+            <a:off x="8347253" y="3941064"/>
+            <a:ext cx="274320" cy="274320"/>
+          </a:xfrm>
+          <a:prstGeom prst="rect">
+            <a:avLst/>
+          </a:prstGeom>
+          <a:noFill/>
+          <a:ln/>
+        </p:spPr>
+        <p:txBody>
+          <a:bodyPr wrap="square" lIns="0" tIns="0" rIns="0" bIns="0" rtlCol="0" anchor="ctr"/>
+          <a:lstStyle/>
+          <a:p>
+            <a:pPr algn="ctr" indent="0" marL="0">
+              <a:buNone/>
+            </a:pPr>
+            <a:r>
+              <a:rPr lang="en-US" sz="1000" b="1" dirty="0">
+                <a:solidFill>
+                  <a:srgbClr val="FFFFFF"/>
+                </a:solidFill>
+                <a:latin typeface="Calibri" pitchFamily="34" charset="0"/>
+                <a:ea typeface="Calibri" pitchFamily="34" charset="-122"/>
+                <a:cs typeface="Calibri" pitchFamily="34" charset="-120"/>
+              </a:rPr>
+              <a:t>1</a:t>
+            </a:r>
+            <a:endParaRPr lang="en-US" sz="1000" dirty="0"/>
+          </a:p>
+        </p:txBody>
+      </p:sp>
+      <p:sp>
+        <p:nvSpPr>
+          <p:cNvPr id="46" name="Text 44"/>
+          <p:cNvSpPr txBox="1"/>
+          <p:nvPr/>
+        </p:nvSpPr>
+        <p:spPr>
+          <a:xfrm>
+            <a:off x="8731301" y="3840480"/>
+            <a:ext cx="2619146" cy="475488"/>
+          </a:xfrm>
+          <a:prstGeom prst="rect">
+            <a:avLst/>
+          </a:prstGeom>
+          <a:noFill/>
+          <a:ln/>
+        </p:spPr>
+        <p:txBody>
+          <a:bodyPr wrap="square" lIns="0" tIns="0" rIns="0" bIns="0" rtlCol="0" anchor="ctr"/>
+          <a:lstStyle/>
+          <a:p>
+            <a:pPr indent="0" marL="0">
+              <a:buNone/>
+            </a:pPr>
+            <a:r>
+              <a:rPr lang="en-US" sz="1100" b="1" dirty="0">
+                <a:solidFill>
+                  <a:srgbClr val="FFFFFF"/>
+                </a:solidFill>
+                <a:latin typeface="Calibri" pitchFamily="34" charset="0"/>
+                <a:ea typeface="Calibri" pitchFamily="34" charset="-122"/>
+                <a:cs typeface="Calibri" pitchFamily="34" charset="-120"/>
+              </a:rPr>
+              <a:t>Pick two pilot ISVs</a:t>
+            </a:r>
+            <a:endParaRPr lang="en-US" sz="1100" dirty="0"/>
+          </a:p>
+        </p:txBody>
+      </p:sp>
+      <p:sp>
+        <p:nvSpPr>
+          <p:cNvPr id="47" name="Shape 45"/>
+          <p:cNvSpPr/>
+          <p:nvPr/>
+        </p:nvSpPr>
+        <p:spPr>
+          <a:xfrm>
+            <a:off x="8347253" y="4507992"/>
+            <a:ext cx="274320" cy="274320"/>
+          </a:xfrm>
+          <a:prstGeom prst="ellipse">
+            <a:avLst/>
+          </a:prstGeom>
+          <a:solidFill>
+            <a:srgbClr val="3B4CC0"/>
+          </a:solidFill>
+          <a:ln w="9525">
+            <a:solidFill>
+              <a:srgbClr val="5566D8"/>
+            </a:solidFill>
+            <a:prstDash val="solid"/>
+          </a:ln>
+        </p:spPr>
+      </p:sp>
+      <p:sp>
+        <p:nvSpPr>
+          <p:cNvPr id="48" name="Text 46"/>
+          <p:cNvSpPr txBox="1"/>
+          <p:nvPr/>
+        </p:nvSpPr>
+        <p:spPr>
+          <a:xfrm>
+            <a:off x="8347253" y="4507992"/>
+            <a:ext cx="274320" cy="274320"/>
+          </a:xfrm>
+          <a:prstGeom prst="rect">
+            <a:avLst/>
+          </a:prstGeom>
+          <a:noFill/>
+          <a:ln/>
+        </p:spPr>
+        <p:txBody>
+          <a:bodyPr wrap="square" lIns="0" tIns="0" rIns="0" bIns="0" rtlCol="0" anchor="ctr"/>
+          <a:lstStyle/>
+          <a:p>
+            <a:pPr algn="ctr" indent="0" marL="0">
+              <a:buNone/>
+            </a:pPr>
+            <a:r>
+              <a:rPr lang="en-US" sz="1000" b="1" dirty="0">
+                <a:solidFill>
+                  <a:srgbClr val="FFFFFF"/>
+                </a:solidFill>
+                <a:latin typeface="Calibri" pitchFamily="34" charset="0"/>
+                <a:ea typeface="Calibri" pitchFamily="34" charset="-122"/>
+                <a:cs typeface="Calibri" pitchFamily="34" charset="-120"/>
+              </a:rPr>
+              <a:t>2</a:t>
+            </a:r>
+            <a:endParaRPr lang="en-US" sz="1000" dirty="0"/>
+          </a:p>
+        </p:txBody>
+      </p:sp>
+      <p:sp>
+        <p:nvSpPr>
+          <p:cNvPr id="49" name="Text 47"/>
+          <p:cNvSpPr txBox="1"/>
+          <p:nvPr/>
+        </p:nvSpPr>
+        <p:spPr>
+          <a:xfrm>
+            <a:off x="8731301" y="4407408"/>
+            <a:ext cx="2619146" cy="475488"/>
+          </a:xfrm>
+          <a:prstGeom prst="rect">
+            <a:avLst/>
+          </a:prstGeom>
+          <a:noFill/>
+          <a:ln/>
+        </p:spPr>
+        <p:txBody>
+          <a:bodyPr wrap="square" lIns="0" tIns="0" rIns="0" bIns="0" rtlCol="0" anchor="ctr"/>
+          <a:lstStyle/>
+          <a:p>
+            <a:pPr indent="0" marL="0">
+              <a:buNone/>
+            </a:pPr>
+            <a:r>
+              <a:rPr lang="en-US" sz="1100" b="1" dirty="0">
+                <a:solidFill>
+                  <a:srgbClr val="FFFFFF"/>
+                </a:solidFill>
+                <a:latin typeface="Calibri" pitchFamily="34" charset="0"/>
+                <a:ea typeface="Calibri" pitchFamily="34" charset="-122"/>
+                <a:cs typeface="Calibri" pitchFamily="34" charset="-120"/>
+              </a:rPr>
+              <a:t>Run the free savings analysis</a:t>
+            </a:r>
+            <a:endParaRPr lang="en-US" sz="1100" dirty="0"/>
+          </a:p>
+        </p:txBody>
+      </p:sp>
+      <p:sp>
+        <p:nvSpPr>
+          <p:cNvPr id="50" name="Shape 48"/>
+          <p:cNvSpPr/>
+          <p:nvPr/>
+        </p:nvSpPr>
+        <p:spPr>
+          <a:xfrm>
+            <a:off x="8347253" y="5074920"/>
+            <a:ext cx="274320" cy="274320"/>
+          </a:xfrm>
+          <a:prstGeom prst="ellipse">
+            <a:avLst/>
+          </a:prstGeom>
+          <a:solidFill>
+            <a:srgbClr val="3B4CC0"/>
+          </a:solidFill>
+          <a:ln w="9525">
+            <a:solidFill>
+              <a:srgbClr val="5566D8"/>
+            </a:solidFill>
+            <a:prstDash val="solid"/>
+          </a:ln>
+        </p:spPr>
+      </p:sp>
+      <p:sp>
+        <p:nvSpPr>
+          <p:cNvPr id="51" name="Text 49"/>
+          <p:cNvSpPr txBox="1"/>
+          <p:nvPr/>
+        </p:nvSpPr>
+        <p:spPr>
+          <a:xfrm>
+            <a:off x="8347253" y="5074920"/>
+            <a:ext cx="274320" cy="274320"/>
+          </a:xfrm>
+          <a:prstGeom prst="rect">
+            <a:avLst/>
+          </a:prstGeom>
+          <a:noFill/>
+          <a:ln/>
+        </p:spPr>
+        <p:txBody>
+          <a:bodyPr wrap="square" lIns="0" tIns="0" rIns="0" bIns="0" rtlCol="0" anchor="ctr"/>
+          <a:lstStyle/>
+          <a:p>
+            <a:pPr algn="ctr" indent="0" marL="0">
+              <a:buNone/>
+            </a:pPr>
+            <a:r>
+              <a:rPr lang="en-US" sz="1000" b="1" dirty="0">
+                <a:solidFill>
+                  <a:srgbClr val="FFFFFF"/>
+                </a:solidFill>
+                <a:latin typeface="Calibri" pitchFamily="34" charset="0"/>
+                <a:ea typeface="Calibri" pitchFamily="34" charset="-122"/>
+                <a:cs typeface="Calibri" pitchFamily="34" charset="-120"/>
+              </a:rPr>
+              <a:t>3</a:t>
+            </a:r>
+            <a:endParaRPr lang="en-US" sz="1000" dirty="0"/>
+          </a:p>
+        </p:txBody>
+      </p:sp>
+      <p:sp>
+        <p:nvSpPr>
+          <p:cNvPr id="52" name="Text 50"/>
+          <p:cNvSpPr txBox="1"/>
+          <p:nvPr/>
+        </p:nvSpPr>
+        <p:spPr>
+          <a:xfrm>
+            <a:off x="8731301" y="4974336"/>
+            <a:ext cx="2619146" cy="475488"/>
+          </a:xfrm>
+          <a:prstGeom prst="rect">
+            <a:avLst/>
+          </a:prstGeom>
+          <a:noFill/>
+          <a:ln/>
+        </p:spPr>
+        <p:txBody>
+          <a:bodyPr wrap="square" lIns="0" tIns="0" rIns="0" bIns="0" rtlCol="0" anchor="ctr"/>
+          <a:lstStyle/>
+          <a:p>
+            <a:pPr indent="0" marL="0">
+              <a:buNone/>
+            </a:pPr>
+            <a:r>
+              <a:rPr lang="en-US" sz="1100" b="1" dirty="0">
+                <a:solidFill>
+                  <a:srgbClr val="FFFFFF"/>
+                </a:solidFill>
+                <a:latin typeface="Calibri" pitchFamily="34" charset="0"/>
+                <a:ea typeface="Calibri" pitchFamily="34" charset="-122"/>
+                <a:cs typeface="Calibri" pitchFamily="34" charset="-120"/>
+              </a:rPr>
+              <a:t>Sign the distributor agreement</a:t>
+            </a:r>
+            <a:endParaRPr lang="en-US" sz="1100" dirty="0"/>
+          </a:p>
+        </p:txBody>
+      </p:sp>
+      <p:sp>
+        <p:nvSpPr>
+          <p:cNvPr id="53" name="Text 51"/>
+          <p:cNvSpPr txBox="1"/>
+          <p:nvPr/>
+        </p:nvSpPr>
+        <p:spPr>
+          <a:xfrm>
+            <a:off x="566928" y="5943600"/>
+            <a:ext cx="11057839" cy="274320"/>
+          </a:xfrm>
+          <a:prstGeom prst="rect">
+            <a:avLst/>
+          </a:prstGeom>
+          <a:noFill/>
+          <a:ln/>
+        </p:spPr>
+        <p:txBody>
+          <a:bodyPr wrap="square" lIns="0" tIns="0" rIns="0" bIns="0" rtlCol="0" anchor="t"/>
+          <a:lstStyle/>
+          <a:p>
+            <a:pPr indent="0" marL="0">
+              <a:lnSpc>
+                <a:spcPts val="1100"/>
+              </a:lnSpc>
+              <a:buNone/>
+            </a:pPr>
+            <a:r>
+              <a:rPr lang="en-US" sz="850" i="1" dirty="0">
+                <a:solidFill>
+                  <a:srgbClr val="5B6486"/>
+                </a:solidFill>
+                <a:latin typeface="Calibri" pitchFamily="34" charset="0"/>
+                <a:ea typeface="Calibri" pitchFamily="34" charset="-122"/>
+                <a:cs typeface="Calibri" pitchFamily="34" charset="-120"/>
+              </a:rPr>
+              <a:t>Figures per this deck: savings vs on-demand from Archera's AWS pricing; tiers per the distributor agreement template (unsigned). Full sources on the slides behind each claim.</a:t>
+            </a:r>
+            <a:endParaRPr lang="en-US" sz="850" dirty="0"/>
+          </a:p>
+        </p:txBody>
+      </p:sp>
+      <p:sp>
+        <p:nvSpPr>
+          <p:cNvPr id="54" name="Text 52"/>
+          <p:cNvSpPr txBox="1"/>
+          <p:nvPr/>
+        </p:nvSpPr>
+        <p:spPr>
+          <a:xfrm>
+            <a:off x="566928" y="6309360"/>
+            <a:ext cx="7315200" cy="274320"/>
+          </a:xfrm>
+          <a:prstGeom prst="rect">
+            <a:avLst/>
+          </a:prstGeom>
+          <a:noFill/>
+          <a:ln/>
+        </p:spPr>
+        <p:txBody>
+          <a:bodyPr wrap="square" lIns="0" tIns="0" rIns="0" bIns="0" rtlCol="0" anchor="ctr"/>
+          <a:lstStyle/>
+          <a:p>
+            <a:pPr indent="0" marL="0">
+              <a:buNone/>
+            </a:pPr>
+            <a:r>
+              <a:rPr lang="en-US" sz="1000" spc="80" kern="0" dirty="0">
+                <a:solidFill>
+                  <a:srgbClr val="5B6486"/>
+                </a:solidFill>
+                <a:latin typeface="Calibri" pitchFamily="34" charset="0"/>
+                <a:ea typeface="Calibri" pitchFamily="34" charset="-122"/>
+                <a:cs typeface="Calibri" pitchFamily="34" charset="-120"/>
+              </a:rPr>
+              <a:t>Prepared by Only Best Practices  ·  AWS Alliance Advisory</a:t>
+            </a:r>
+            <a:endParaRPr lang="en-US" sz="1000" dirty="0"/>
+          </a:p>
+        </p:txBody>
+      </p:sp>
+      <p:sp>
+        <p:nvSpPr>
+          <p:cNvPr id="55" name="Text 53"/>
+          <p:cNvSpPr txBox="1"/>
+          <p:nvPr/>
+        </p:nvSpPr>
+        <p:spPr>
+          <a:xfrm>
+            <a:off x="10527487" y="6309360"/>
+            <a:ext cx="1097280" cy="274320"/>
+          </a:xfrm>
+          <a:prstGeom prst="rect">
+            <a:avLst/>
+          </a:prstGeom>
+          <a:noFill/>
+          <a:ln/>
+        </p:spPr>
+        <p:txBody>
+          <a:bodyPr wrap="square" lIns="0" tIns="0" rIns="0" bIns="0" rtlCol="0" anchor="ctr"/>
+          <a:lstStyle/>
+          <a:p>
+            <a:pPr algn="r" indent="0" marL="0">
+              <a:buNone/>
+            </a:pPr>
+            <a:r>
+              <a:rPr lang="en-US" sz="900" dirty="0">
+                <a:solidFill>
+                  <a:srgbClr val="5B6486"/>
+                </a:solidFill>
+                <a:latin typeface="Calibri" pitchFamily="34" charset="0"/>
+                <a:ea typeface="Calibri" pitchFamily="34" charset="-122"/>
+                <a:cs typeface="Calibri" pitchFamily="34" charset="-120"/>
+              </a:rPr>
+              <a:t>21</a:t>
+            </a:r>
+            <a:endParaRPr lang="en-US" sz="900" dirty="0"/>
+          </a:p>
+        </p:txBody>
+      </p:sp>
+    </p:spTree>
+  </p:cSld>
+  <p:clrMapOvr>
+    <a:masterClrMapping/>
+  </p:clrMapOvr>
+</p:sld>
+</file>
+
 <file path=ppt/slides/slide3.xml><?xml version="1.0" encoding="utf-8"?>
 <p:sld xmlns:a="http://schemas.openxmlformats.org/drawingml/2006/main" xmlns:r="http://schemas.openxmlformats.org/officeDocument/2006/relationships" xmlns:p="http://schemas.openxmlformats.org/presentationml/2006/main">
   <p:cSld name="Slide 3">
@@ -18519,19 +20863,22 @@
         <p:spPr>
           <a:xfrm>
             <a:off x="566928" y="5340096"/>
-            <a:ext cx="11057839" cy="365760"/>
-          </a:xfrm>
-          <a:prstGeom prst="rect">
-            <a:avLst/>
-          </a:prstGeom>
-          <a:noFill/>
-          <a:ln/>
-        </p:spPr>
-        <p:txBody>
-          <a:bodyPr wrap="square" lIns="0" tIns="0" rIns="0" bIns="0" rtlCol="0" anchor="ctr"/>
-          <a:lstStyle/>
-          <a:p>
-            <a:pPr indent="0" marL="0">
+            <a:ext cx="11057839" cy="566928"/>
+          </a:xfrm>
+          <a:prstGeom prst="rect">
+            <a:avLst/>
+          </a:prstGeom>
+          <a:noFill/>
+          <a:ln/>
+        </p:spPr>
+        <p:txBody>
+          <a:bodyPr wrap="square" lIns="0" tIns="0" rIns="0" bIns="0" rtlCol="0" anchor="t"/>
+          <a:lstStyle/>
+          <a:p>
+            <a:pPr indent="0" marL="0">
+              <a:lnSpc>
+                <a:spcPts val="1900"/>
+              </a:lnSpc>
               <a:buNone/>
             </a:pPr>
             <a:r>
@@ -18546,6 +20893,9 @@
               <a:t>The first one is the point. </a:t>
             </a:r>
             <a:pPr indent="0" marL="0">
+              <a:lnSpc>
+                <a:spcPts val="1900"/>
+              </a:lnSpc>
               <a:buNone/>
             </a:pPr>
             <a:r>
@@ -18557,7 +20907,7 @@
                 <a:ea typeface="Calibri" pitchFamily="34" charset="-122"/>
                 <a:cs typeface="Calibri" pitchFamily="34" charset="-120"/>
               </a:rPr>
-              <a:t>The other three compound on top of it — and part four runs them as five motions, starting with the attach, which works on day one.</a:t>
+              <a:t>The other three compound on top of it — and part four runs them as five motions, starting with the attach, which works on day one. One clock to respect: rev-share counts only entities net-new to Archera.</a:t>
             </a:r>
             <a:endParaRPr lang="en-US" sz="1300" dirty="0"/>
           </a:p>
@@ -23318,7 +25668,7 @@
                 <a:ea typeface="Calibri" pitchFamily="34" charset="-122"/>
                 <a:cs typeface="Calibri" pitchFamily="34" charset="-120"/>
               </a:rPr>
-              <a:t>Illustrative. Reservable share and the blended Archera rate are assumptions; the 45% coverage gap follows the measured 55% median AWS commitment coverage (ProsperOps). The 22% premium is the gap between the 57% a three-year creates and the 35% blended net the customer keeps. Rev-share tiers per Archera's distributor agreement: Bronze 20% (under $100K GRI/GSP MRR), Silver 25% (under $500K), Gold 30% ($1M+) — the base case's ~$119K premium MRR lands in Silver.</a:t>
+              <a:t>Illustrative. Reservable share and the blended Archera rate are assumptions; the 45% coverage gap follows the measured 55% median AWS commitment coverage (ProsperOps). The 22% premium is the gap between the 57% a three-year creates and the 35% blended net the customer keeps. Rev-share tiers per Archera's distributor agreement: Bronze 20% (under $100K commitment MRR), Silver 25% (under $500K), Gold 30% ($1M+) — the base case's ~$119K premium MRR lands in Silver.</a:t>
             </a:r>
             <a:endParaRPr lang="en-US" sz="850" dirty="0"/>
           </a:p>

</xml_diff>